<commit_message>
Add the architecture and the numbered conclusion to the deck
The deck showed the stack as two lists and never showed how the pieces fit, so
the one slide a technical judge would look hardest at was the thinnest. The
architecture slide draws it: what the shop provides, what persists between runs
including the notes file, and the agent with its tool groups and its hook. It
also separates what happens all day from what happens at closing, which the deck
had never distinguished.

The conclusion slide carries the three figures. Two are measured: about 5,000
euros a year recovered, from the 120 day counterfactual, and about 25 dollars a
year to run, from the token weight of a real run's tool output at Sonnet rates.
The seven hours a week is an estimate of what these jobs take by hand and says
so on the card, because nobody timed a bakery owner.
</commit_message>
<xml_diff>
--- a/docs/Sonnabon.pptx
+++ b/docs/Sonnabon.pptx
@@ -15,9 +15,10 @@
     <p:sldId id="263" r:id="rId9"/>
     <p:sldId id="264" r:id="rId10"/>
     <p:sldId id="265" r:id="rId11"/>
+    <p:sldId id="266" r:id="rId12"/>
   </p:sldIdLst>
   <p:notesMasterIdLst>
-    <p:notesMasterId r:id="rId12"/>
+    <p:notesMasterId r:id="rId13"/>
   </p:notesMasterIdLst>
   <p:sldSz cx="12192000" cy="6858000"/>
   <p:notesSz cx="6858000" cy="12192000"/>
@@ -1295,6 +1296,94 @@
             <a:fld id="{F7021451-1387-4CA6-816F-3879F97B5CBC}" type="slidenum">
               <a:rPr lang="en-US"/>
               <a:t>10</a:t>
+            </a:fld>
+            <a:endParaRPr lang="en-US"/>
+          </a:p>
+        </p:txBody>
+      </p:sp>
+    </p:spTree>
+    <p:extLst>
+      <p:ext uri="{BB962C8B-B14F-4D97-AF65-F5344CB8AC3E}">
+        <p14:creationId xmlns:p14="http://schemas.microsoft.com/office/powerpoint/2010/main" val="1024086991"/>
+      </p:ext>
+    </p:extLst>
+  </p:cSld>
+  <p:clrMapOvr>
+    <a:masterClrMapping/>
+  </p:clrMapOvr>
+</p:notes>
+</file>
+
+<file path=ppt/notesSlides/notesSlide11.xml><?xml version="1.0" encoding="utf-8"?>
+<p:notes xmlns:a="http://schemas.openxmlformats.org/drawingml/2006/main" xmlns:r="http://schemas.openxmlformats.org/officeDocument/2006/relationships" xmlns:p="http://schemas.openxmlformats.org/presentationml/2006/main">
+  <p:cSld>
+    <p:spTree>
+      <p:nvGrpSpPr>
+        <p:cNvPr id="1" name=""/>
+        <p:cNvGrpSpPr/>
+        <p:nvPr/>
+      </p:nvGrpSpPr>
+      <p:grpSpPr>
+        <a:xfrm>
+          <a:off x="0" y="0"/>
+          <a:ext cx="0" cy="0"/>
+          <a:chOff x="0" y="0"/>
+          <a:chExt cx="0" cy="0"/>
+        </a:xfrm>
+      </p:grpSpPr>
+      <p:sp>
+        <p:nvSpPr>
+          <p:cNvPr id="2" name="Slide Image Placeholder 1"/>
+          <p:cNvSpPr>
+            <a:spLocks noGrp="1" noRot="1" noChangeAspect="1"/>
+          </p:cNvSpPr>
+          <p:nvPr>
+            <p:ph type="sldImg"/>
+          </p:nvPr>
+        </p:nvSpPr>
+        <p:spPr/>
+      </p:sp>
+      <p:sp>
+        <p:nvSpPr>
+          <p:cNvPr id="3" name="Notes Placeholder 2"/>
+          <p:cNvSpPr>
+            <a:spLocks noGrp="1"/>
+          </p:cNvSpPr>
+          <p:nvPr>
+            <p:ph type="body" idx="1"/>
+          </p:nvPr>
+        </p:nvSpPr>
+        <p:spPr/>
+        <p:txBody>
+          <a:bodyPr/>
+          <a:lstStyle/>
+          <a:p>
+            <a:r>
+              <a:rPr lang="en-US" dirty="0"/>
+              <a:t/>
+            </a:r>
+            <a:endParaRPr lang="en-US" dirty="0"/>
+          </a:p>
+        </p:txBody>
+      </p:sp>
+      <p:sp>
+        <p:nvSpPr>
+          <p:cNvPr id="4" name="Slide Number Placeholder 3"/>
+          <p:cNvSpPr>
+            <a:spLocks noGrp="1"/>
+          </p:cNvSpPr>
+          <p:nvPr>
+            <p:ph type="sldNum" sz="quarter" idx="10"/>
+          </p:nvPr>
+        </p:nvSpPr>
+        <p:spPr/>
+        <p:txBody>
+          <a:bodyPr/>
+          <a:lstStyle/>
+          <a:p>
+            <a:fld id="{F7021451-1387-4CA6-816F-3879F97B5CBC}" type="slidenum">
+              <a:rPr lang="en-US"/>
+              <a:t>11</a:t>
             </a:fld>
             <a:endParaRPr lang="en-US"/>
           </a:p>
@@ -2523,6 +2612,954 @@
     <p:bg>
       <p:bgPr>
         <a:solidFill>
+          <a:srgbClr val="F4F9FD"/>
+        </a:solidFill>
+      </p:bgPr>
+    </p:bg>
+    <p:spTree>
+      <p:nvGrpSpPr>
+        <p:cNvPr id="1" name=""/>
+        <p:cNvGrpSpPr/>
+        <p:nvPr/>
+      </p:nvGrpSpPr>
+      <p:grpSpPr>
+        <a:xfrm>
+          <a:off x="0" y="0"/>
+          <a:ext cx="0" cy="0"/>
+          <a:chOff x="0" y="0"/>
+          <a:chExt cx="0" cy="0"/>
+        </a:xfrm>
+      </p:grpSpPr>
+      <p:sp>
+        <p:nvSpPr>
+          <p:cNvPr id="2" name="Shape 0"/>
+          <p:cNvSpPr/>
+          <p:nvPr/>
+        </p:nvSpPr>
+        <p:spPr>
+          <a:xfrm>
+            <a:off x="566928" y="420624"/>
+            <a:ext cx="402336" cy="402336"/>
+          </a:xfrm>
+          <a:prstGeom prst="ellipse">
+            <a:avLst/>
+          </a:prstGeom>
+          <a:solidFill>
+            <a:srgbClr val="5B9BD1"/>
+          </a:solidFill>
+          <a:ln/>
+        </p:spPr>
+      </p:sp>
+      <p:sp>
+        <p:nvSpPr>
+          <p:cNvPr id="3" name="Text 1"/>
+          <p:cNvSpPr/>
+          <p:nvPr/>
+        </p:nvSpPr>
+        <p:spPr>
+          <a:xfrm>
+            <a:off x="566928" y="420624"/>
+            <a:ext cx="402336" cy="402336"/>
+          </a:xfrm>
+          <a:prstGeom prst="rect">
+            <a:avLst/>
+          </a:prstGeom>
+          <a:noFill/>
+          <a:ln/>
+        </p:spPr>
+        <p:txBody>
+          <a:bodyPr wrap="square" lIns="0" tIns="0" rIns="0" bIns="0" rtlCol="0" anchor="ctr"/>
+          <a:lstStyle/>
+          <a:p>
+            <a:pPr algn="ctr" indent="0" marL="0">
+              <a:buNone/>
+            </a:pPr>
+            <a:r>
+              <a:rPr lang="en-US" sz="1400" b="1" dirty="0">
+                <a:solidFill>
+                  <a:srgbClr val="FFFFFF"/>
+                </a:solidFill>
+                <a:latin typeface="Calibri" pitchFamily="34" charset="0"/>
+                <a:ea typeface="Calibri" pitchFamily="34" charset="-122"/>
+                <a:cs typeface="Calibri" pitchFamily="34" charset="-120"/>
+              </a:rPr>
+              <a:t>10</a:t>
+            </a:r>
+            <a:endParaRPr lang="en-US" sz="1400" dirty="0"/>
+          </a:p>
+        </p:txBody>
+      </p:sp>
+      <p:sp>
+        <p:nvSpPr>
+          <p:cNvPr id="4" name="Text 2"/>
+          <p:cNvSpPr/>
+          <p:nvPr/>
+        </p:nvSpPr>
+        <p:spPr>
+          <a:xfrm>
+            <a:off x="1097280" y="420624"/>
+            <a:ext cx="7315200" cy="402336"/>
+          </a:xfrm>
+          <a:prstGeom prst="rect">
+            <a:avLst/>
+          </a:prstGeom>
+          <a:noFill/>
+          <a:ln/>
+        </p:spPr>
+        <p:txBody>
+          <a:bodyPr wrap="square" lIns="0" tIns="0" rIns="0" bIns="0" rtlCol="0" anchor="ctr"/>
+          <a:lstStyle/>
+          <a:p>
+            <a:pPr indent="0" marL="0">
+              <a:buNone/>
+            </a:pPr>
+            <a:r>
+              <a:rPr lang="en-US" sz="1100" spc="200" kern="0" dirty="0">
+                <a:solidFill>
+                  <a:srgbClr val="5A7186"/>
+                </a:solidFill>
+                <a:latin typeface="Calibri" pitchFamily="34" charset="0"/>
+                <a:ea typeface="Calibri" pitchFamily="34" charset="-122"/>
+                <a:cs typeface="Calibri" pitchFamily="34" charset="-120"/>
+              </a:rPr>
+              <a:t>WHAT IT RETURNS</a:t>
+            </a:r>
+            <a:endParaRPr lang="en-US" sz="1100" dirty="0"/>
+          </a:p>
+        </p:txBody>
+      </p:sp>
+      <p:sp>
+        <p:nvSpPr>
+          <p:cNvPr id="5" name="Text 3"/>
+          <p:cNvSpPr/>
+          <p:nvPr/>
+        </p:nvSpPr>
+        <p:spPr>
+          <a:xfrm>
+            <a:off x="566928" y="950976"/>
+            <a:ext cx="11064240" cy="822960"/>
+          </a:xfrm>
+          <a:prstGeom prst="rect">
+            <a:avLst/>
+          </a:prstGeom>
+          <a:noFill/>
+          <a:ln/>
+        </p:spPr>
+        <p:txBody>
+          <a:bodyPr wrap="square" lIns="0" tIns="0" rIns="0" bIns="0" rtlCol="0" anchor="ctr"/>
+          <a:lstStyle/>
+          <a:p>
+            <a:pPr indent="0" marL="0">
+              <a:buNone/>
+            </a:pPr>
+            <a:r>
+              <a:rPr lang="en-US" sz="3600" b="1" dirty="0">
+                <a:solidFill>
+                  <a:srgbClr val="22384C"/>
+                </a:solidFill>
+                <a:latin typeface="Georgia" pitchFamily="34" charset="0"/>
+                <a:ea typeface="Georgia" pitchFamily="34" charset="-122"/>
+                <a:cs typeface="Georgia" pitchFamily="34" charset="-120"/>
+              </a:rPr>
+              <a:t>What Sarah gets back</a:t>
+            </a:r>
+            <a:endParaRPr lang="en-US" sz="3600" dirty="0"/>
+          </a:p>
+        </p:txBody>
+      </p:sp>
+      <p:sp>
+        <p:nvSpPr>
+          <p:cNvPr id="6" name="Shape 4"/>
+          <p:cNvSpPr/>
+          <p:nvPr/>
+        </p:nvSpPr>
+        <p:spPr>
+          <a:xfrm>
+            <a:off x="566928" y="1865376"/>
+            <a:ext cx="3547872" cy="2249424"/>
+          </a:xfrm>
+          <a:prstGeom prst="roundRect">
+            <a:avLst>
+              <a:gd name="adj" fmla="val 4065"/>
+            </a:avLst>
+          </a:prstGeom>
+          <a:solidFill>
+            <a:srgbClr val="FFFFFF"/>
+          </a:solidFill>
+          <a:ln w="12700">
+            <a:solidFill>
+              <a:srgbClr val="DCE6EF"/>
+            </a:solidFill>
+            <a:prstDash val="solid"/>
+          </a:ln>
+        </p:spPr>
+      </p:sp>
+      <p:sp>
+        <p:nvSpPr>
+          <p:cNvPr id="7" name="Shape 5"/>
+          <p:cNvSpPr/>
+          <p:nvPr/>
+        </p:nvSpPr>
+        <p:spPr>
+          <a:xfrm>
+            <a:off x="566928" y="1865376"/>
+            <a:ext cx="3547872" cy="73152"/>
+          </a:xfrm>
+          <a:prstGeom prst="rect">
+            <a:avLst/>
+          </a:prstGeom>
+          <a:solidFill>
+            <a:srgbClr val="5B9BD1"/>
+          </a:solidFill>
+          <a:ln/>
+        </p:spPr>
+      </p:sp>
+      <p:sp>
+        <p:nvSpPr>
+          <p:cNvPr id="8" name="Text 6"/>
+          <p:cNvSpPr/>
+          <p:nvPr/>
+        </p:nvSpPr>
+        <p:spPr>
+          <a:xfrm>
+            <a:off x="822960" y="2066544"/>
+            <a:ext cx="3035808" cy="256032"/>
+          </a:xfrm>
+          <a:prstGeom prst="rect">
+            <a:avLst/>
+          </a:prstGeom>
+          <a:noFill/>
+          <a:ln/>
+        </p:spPr>
+        <p:txBody>
+          <a:bodyPr wrap="square" lIns="0" tIns="0" rIns="0" bIns="0" rtlCol="0" anchor="ctr"/>
+          <a:lstStyle/>
+          <a:p>
+            <a:pPr indent="0" marL="0">
+              <a:buNone/>
+            </a:pPr>
+            <a:r>
+              <a:rPr lang="en-US" sz="1050" b="1" spc="140" kern="0" dirty="0">
+                <a:solidFill>
+                  <a:srgbClr val="3276B1"/>
+                </a:solidFill>
+                <a:latin typeface="Calibri" pitchFamily="34" charset="0"/>
+                <a:ea typeface="Calibri" pitchFamily="34" charset="-122"/>
+                <a:cs typeface="Calibri" pitchFamily="34" charset="-120"/>
+              </a:rPr>
+              <a:t>THE TIME</a:t>
+            </a:r>
+            <a:endParaRPr lang="en-US" sz="1050" dirty="0"/>
+          </a:p>
+        </p:txBody>
+      </p:sp>
+      <p:sp>
+        <p:nvSpPr>
+          <p:cNvPr id="9" name="Text 7"/>
+          <p:cNvSpPr/>
+          <p:nvPr/>
+        </p:nvSpPr>
+        <p:spPr>
+          <a:xfrm>
+            <a:off x="822960" y="2395728"/>
+            <a:ext cx="3035808" cy="694944"/>
+          </a:xfrm>
+          <a:prstGeom prst="rect">
+            <a:avLst/>
+          </a:prstGeom>
+          <a:noFill/>
+          <a:ln/>
+        </p:spPr>
+        <p:txBody>
+          <a:bodyPr wrap="square" lIns="0" tIns="0" rIns="0" bIns="0" rtlCol="0" anchor="ctr"/>
+          <a:lstStyle/>
+          <a:p>
+            <a:pPr indent="0" marL="0">
+              <a:buNone/>
+            </a:pPr>
+            <a:r>
+              <a:rPr lang="en-US" sz="4000" b="1" dirty="0">
+                <a:solidFill>
+                  <a:srgbClr val="22384C"/>
+                </a:solidFill>
+                <a:latin typeface="Georgia" pitchFamily="34" charset="0"/>
+                <a:ea typeface="Georgia" pitchFamily="34" charset="-122"/>
+                <a:cs typeface="Georgia" pitchFamily="34" charset="-120"/>
+              </a:rPr>
+              <a:t>7 h</a:t>
+            </a:r>
+            <a:endParaRPr lang="en-US" sz="4000" dirty="0"/>
+          </a:p>
+        </p:txBody>
+      </p:sp>
+      <p:sp>
+        <p:nvSpPr>
+          <p:cNvPr id="10" name="Text 8"/>
+          <p:cNvSpPr/>
+          <p:nvPr/>
+        </p:nvSpPr>
+        <p:spPr>
+          <a:xfrm>
+            <a:off x="822960" y="3127248"/>
+            <a:ext cx="3035808" cy="292608"/>
+          </a:xfrm>
+          <a:prstGeom prst="rect">
+            <a:avLst/>
+          </a:prstGeom>
+          <a:noFill/>
+          <a:ln/>
+        </p:spPr>
+        <p:txBody>
+          <a:bodyPr wrap="square" lIns="0" tIns="0" rIns="0" bIns="0" rtlCol="0" anchor="ctr"/>
+          <a:lstStyle/>
+          <a:p>
+            <a:pPr indent="0" marL="0">
+              <a:buNone/>
+            </a:pPr>
+            <a:r>
+              <a:rPr lang="en-US" sz="1350" dirty="0">
+                <a:solidFill>
+                  <a:srgbClr val="22384C"/>
+                </a:solidFill>
+                <a:latin typeface="Calibri" pitchFamily="34" charset="0"/>
+                <a:ea typeface="Calibri" pitchFamily="34" charset="-122"/>
+                <a:cs typeface="Calibri" pitchFamily="34" charset="-120"/>
+              </a:rPr>
+              <a:t>a week, handed back</a:t>
+            </a:r>
+            <a:endParaRPr lang="en-US" sz="1350" dirty="0"/>
+          </a:p>
+        </p:txBody>
+      </p:sp>
+      <p:sp>
+        <p:nvSpPr>
+          <p:cNvPr id="11" name="Text 9"/>
+          <p:cNvSpPr/>
+          <p:nvPr/>
+        </p:nvSpPr>
+        <p:spPr>
+          <a:xfrm>
+            <a:off x="822960" y="3456432"/>
+            <a:ext cx="3035808" cy="457200"/>
+          </a:xfrm>
+          <a:prstGeom prst="rect">
+            <a:avLst/>
+          </a:prstGeom>
+          <a:noFill/>
+          <a:ln/>
+        </p:spPr>
+        <p:txBody>
+          <a:bodyPr wrap="square" lIns="0" tIns="0" rIns="0" bIns="0" rtlCol="0" anchor="ctr"/>
+          <a:lstStyle/>
+          <a:p>
+            <a:pPr indent="0" marL="0">
+              <a:lnSpc>
+                <a:spcPts val="1400"/>
+              </a:lnSpc>
+              <a:buNone/>
+            </a:pPr>
+            <a:r>
+              <a:rPr lang="en-US" sz="1050" dirty="0">
+                <a:solidFill>
+                  <a:srgbClr val="5A7186"/>
+                </a:solidFill>
+                <a:latin typeface="Calibri" pitchFamily="34" charset="0"/>
+                <a:ea typeface="Calibri" pitchFamily="34" charset="-122"/>
+                <a:cs typeface="Calibri" pitchFamily="34" charset="-120"/>
+              </a:rPr>
+              <a:t>About 375 hours a year. An estimate of what these jobs take by hand.</a:t>
+            </a:r>
+            <a:endParaRPr lang="en-US" sz="1050" dirty="0"/>
+          </a:p>
+        </p:txBody>
+      </p:sp>
+      <p:sp>
+        <p:nvSpPr>
+          <p:cNvPr id="12" name="Shape 10"/>
+          <p:cNvSpPr/>
+          <p:nvPr/>
+        </p:nvSpPr>
+        <p:spPr>
+          <a:xfrm>
+            <a:off x="4315968" y="1865376"/>
+            <a:ext cx="3547872" cy="2249424"/>
+          </a:xfrm>
+          <a:prstGeom prst="roundRect">
+            <a:avLst>
+              <a:gd name="adj" fmla="val 4065"/>
+            </a:avLst>
+          </a:prstGeom>
+          <a:solidFill>
+            <a:srgbClr val="FFFFFF"/>
+          </a:solidFill>
+          <a:ln w="12700">
+            <a:solidFill>
+              <a:srgbClr val="DCE6EF"/>
+            </a:solidFill>
+            <a:prstDash val="solid"/>
+          </a:ln>
+        </p:spPr>
+      </p:sp>
+      <p:sp>
+        <p:nvSpPr>
+          <p:cNvPr id="13" name="Shape 11"/>
+          <p:cNvSpPr/>
+          <p:nvPr/>
+        </p:nvSpPr>
+        <p:spPr>
+          <a:xfrm>
+            <a:off x="4315968" y="1865376"/>
+            <a:ext cx="3547872" cy="73152"/>
+          </a:xfrm>
+          <a:prstGeom prst="rect">
+            <a:avLst/>
+          </a:prstGeom>
+          <a:solidFill>
+            <a:srgbClr val="5B9BD1"/>
+          </a:solidFill>
+          <a:ln/>
+        </p:spPr>
+      </p:sp>
+      <p:sp>
+        <p:nvSpPr>
+          <p:cNvPr id="14" name="Text 12"/>
+          <p:cNvSpPr/>
+          <p:nvPr/>
+        </p:nvSpPr>
+        <p:spPr>
+          <a:xfrm>
+            <a:off x="4572000" y="2066544"/>
+            <a:ext cx="3035808" cy="256032"/>
+          </a:xfrm>
+          <a:prstGeom prst="rect">
+            <a:avLst/>
+          </a:prstGeom>
+          <a:noFill/>
+          <a:ln/>
+        </p:spPr>
+        <p:txBody>
+          <a:bodyPr wrap="square" lIns="0" tIns="0" rIns="0" bIns="0" rtlCol="0" anchor="ctr"/>
+          <a:lstStyle/>
+          <a:p>
+            <a:pPr indent="0" marL="0">
+              <a:buNone/>
+            </a:pPr>
+            <a:r>
+              <a:rPr lang="en-US" sz="1050" b="1" spc="140" kern="0" dirty="0">
+                <a:solidFill>
+                  <a:srgbClr val="3276B1"/>
+                </a:solidFill>
+                <a:latin typeface="Calibri" pitchFamily="34" charset="0"/>
+                <a:ea typeface="Calibri" pitchFamily="34" charset="-122"/>
+                <a:cs typeface="Calibri" pitchFamily="34" charset="-120"/>
+              </a:rPr>
+              <a:t>THE MONEY</a:t>
+            </a:r>
+            <a:endParaRPr lang="en-US" sz="1050" dirty="0"/>
+          </a:p>
+        </p:txBody>
+      </p:sp>
+      <p:sp>
+        <p:nvSpPr>
+          <p:cNvPr id="15" name="Text 13"/>
+          <p:cNvSpPr/>
+          <p:nvPr/>
+        </p:nvSpPr>
+        <p:spPr>
+          <a:xfrm>
+            <a:off x="4572000" y="2395728"/>
+            <a:ext cx="3035808" cy="694944"/>
+          </a:xfrm>
+          <a:prstGeom prst="rect">
+            <a:avLst/>
+          </a:prstGeom>
+          <a:noFill/>
+          <a:ln/>
+        </p:spPr>
+        <p:txBody>
+          <a:bodyPr wrap="square" lIns="0" tIns="0" rIns="0" bIns="0" rtlCol="0" anchor="ctr"/>
+          <a:lstStyle/>
+          <a:p>
+            <a:pPr indent="0" marL="0">
+              <a:buNone/>
+            </a:pPr>
+            <a:r>
+              <a:rPr lang="en-US" sz="4000" b="1" dirty="0">
+                <a:solidFill>
+                  <a:srgbClr val="22384C"/>
+                </a:solidFill>
+                <a:latin typeface="Georgia" pitchFamily="34" charset="0"/>
+                <a:ea typeface="Georgia" pitchFamily="34" charset="-122"/>
+                <a:cs typeface="Georgia" pitchFamily="34" charset="-120"/>
+              </a:rPr>
+              <a:t>€5,000</a:t>
+            </a:r>
+            <a:endParaRPr lang="en-US" sz="4000" dirty="0"/>
+          </a:p>
+        </p:txBody>
+      </p:sp>
+      <p:sp>
+        <p:nvSpPr>
+          <p:cNvPr id="16" name="Text 14"/>
+          <p:cNvSpPr/>
+          <p:nvPr/>
+        </p:nvSpPr>
+        <p:spPr>
+          <a:xfrm>
+            <a:off x="4572000" y="3127248"/>
+            <a:ext cx="3035808" cy="292608"/>
+          </a:xfrm>
+          <a:prstGeom prst="rect">
+            <a:avLst/>
+          </a:prstGeom>
+          <a:noFill/>
+          <a:ln/>
+        </p:spPr>
+        <p:txBody>
+          <a:bodyPr wrap="square" lIns="0" tIns="0" rIns="0" bIns="0" rtlCol="0" anchor="ctr"/>
+          <a:lstStyle/>
+          <a:p>
+            <a:pPr indent="0" marL="0">
+              <a:buNone/>
+            </a:pPr>
+            <a:r>
+              <a:rPr lang="en-US" sz="1350" dirty="0">
+                <a:solidFill>
+                  <a:srgbClr val="22384C"/>
+                </a:solidFill>
+                <a:latin typeface="Calibri" pitchFamily="34" charset="0"/>
+                <a:ea typeface="Calibri" pitchFamily="34" charset="-122"/>
+                <a:cs typeface="Calibri" pitchFamily="34" charset="-120"/>
+              </a:rPr>
+              <a:t>a year, recovered</a:t>
+            </a:r>
+            <a:endParaRPr lang="en-US" sz="1350" dirty="0"/>
+          </a:p>
+        </p:txBody>
+      </p:sp>
+      <p:sp>
+        <p:nvSpPr>
+          <p:cNvPr id="17" name="Text 15"/>
+          <p:cNvSpPr/>
+          <p:nvPr/>
+        </p:nvSpPr>
+        <p:spPr>
+          <a:xfrm>
+            <a:off x="4572000" y="3456432"/>
+            <a:ext cx="3035808" cy="457200"/>
+          </a:xfrm>
+          <a:prstGeom prst="rect">
+            <a:avLst/>
+          </a:prstGeom>
+          <a:noFill/>
+          <a:ln/>
+        </p:spPr>
+        <p:txBody>
+          <a:bodyPr wrap="square" lIns="0" tIns="0" rIns="0" bIns="0" rtlCol="0" anchor="ctr"/>
+          <a:lstStyle/>
+          <a:p>
+            <a:pPr indent="0" marL="0">
+              <a:lnSpc>
+                <a:spcPts val="1400"/>
+              </a:lnSpc>
+              <a:buNone/>
+            </a:pPr>
+            <a:r>
+              <a:rPr lang="en-US" sz="1050" dirty="0">
+                <a:solidFill>
+                  <a:srgbClr val="5A7186"/>
+                </a:solidFill>
+                <a:latin typeface="Calibri" pitchFamily="34" charset="0"/>
+                <a:ea typeface="Calibri" pitchFamily="34" charset="-122"/>
+                <a:cs typeface="Calibri" pitchFamily="34" charset="-120"/>
+              </a:rPr>
+              <a:t>Measured over 120 replayed days. Lost sales fall from €8,321 to €3,690.</a:t>
+            </a:r>
+            <a:endParaRPr lang="en-US" sz="1050" dirty="0"/>
+          </a:p>
+        </p:txBody>
+      </p:sp>
+      <p:sp>
+        <p:nvSpPr>
+          <p:cNvPr id="18" name="Shape 16"/>
+          <p:cNvSpPr/>
+          <p:nvPr/>
+        </p:nvSpPr>
+        <p:spPr>
+          <a:xfrm>
+            <a:off x="8065008" y="1865376"/>
+            <a:ext cx="3566160" cy="2249424"/>
+          </a:xfrm>
+          <a:prstGeom prst="roundRect">
+            <a:avLst>
+              <a:gd name="adj" fmla="val 4065"/>
+            </a:avLst>
+          </a:prstGeom>
+          <a:solidFill>
+            <a:srgbClr val="FFFFFF"/>
+          </a:solidFill>
+          <a:ln w="12700">
+            <a:solidFill>
+              <a:srgbClr val="DCE6EF"/>
+            </a:solidFill>
+            <a:prstDash val="solid"/>
+          </a:ln>
+        </p:spPr>
+      </p:sp>
+      <p:sp>
+        <p:nvSpPr>
+          <p:cNvPr id="19" name="Shape 17"/>
+          <p:cNvSpPr/>
+          <p:nvPr/>
+        </p:nvSpPr>
+        <p:spPr>
+          <a:xfrm>
+            <a:off x="8065008" y="1865376"/>
+            <a:ext cx="3566160" cy="73152"/>
+          </a:xfrm>
+          <a:prstGeom prst="rect">
+            <a:avLst/>
+          </a:prstGeom>
+          <a:solidFill>
+            <a:srgbClr val="CD395F"/>
+          </a:solidFill>
+          <a:ln/>
+        </p:spPr>
+      </p:sp>
+      <p:sp>
+        <p:nvSpPr>
+          <p:cNvPr id="20" name="Text 18"/>
+          <p:cNvSpPr/>
+          <p:nvPr/>
+        </p:nvSpPr>
+        <p:spPr>
+          <a:xfrm>
+            <a:off x="8321040" y="2066544"/>
+            <a:ext cx="3054096" cy="256032"/>
+          </a:xfrm>
+          <a:prstGeom prst="rect">
+            <a:avLst/>
+          </a:prstGeom>
+          <a:noFill/>
+          <a:ln/>
+        </p:spPr>
+        <p:txBody>
+          <a:bodyPr wrap="square" lIns="0" tIns="0" rIns="0" bIns="0" rtlCol="0" anchor="ctr"/>
+          <a:lstStyle/>
+          <a:p>
+            <a:pPr indent="0" marL="0">
+              <a:buNone/>
+            </a:pPr>
+            <a:r>
+              <a:rPr lang="en-US" sz="1050" b="1" spc="140" kern="0" dirty="0">
+                <a:solidFill>
+                  <a:srgbClr val="3276B1"/>
+                </a:solidFill>
+                <a:latin typeface="Calibri" pitchFamily="34" charset="0"/>
+                <a:ea typeface="Calibri" pitchFamily="34" charset="-122"/>
+                <a:cs typeface="Calibri" pitchFamily="34" charset="-120"/>
+              </a:rPr>
+              <a:t>THE COST</a:t>
+            </a:r>
+            <a:endParaRPr lang="en-US" sz="1050" dirty="0"/>
+          </a:p>
+        </p:txBody>
+      </p:sp>
+      <p:sp>
+        <p:nvSpPr>
+          <p:cNvPr id="21" name="Text 19"/>
+          <p:cNvSpPr/>
+          <p:nvPr/>
+        </p:nvSpPr>
+        <p:spPr>
+          <a:xfrm>
+            <a:off x="8321040" y="2395728"/>
+            <a:ext cx="3054096" cy="694944"/>
+          </a:xfrm>
+          <a:prstGeom prst="rect">
+            <a:avLst/>
+          </a:prstGeom>
+          <a:noFill/>
+          <a:ln/>
+        </p:spPr>
+        <p:txBody>
+          <a:bodyPr wrap="square" lIns="0" tIns="0" rIns="0" bIns="0" rtlCol="0" anchor="ctr"/>
+          <a:lstStyle/>
+          <a:p>
+            <a:pPr indent="0" marL="0">
+              <a:buNone/>
+            </a:pPr>
+            <a:r>
+              <a:rPr lang="en-US" sz="4000" b="1" dirty="0">
+                <a:solidFill>
+                  <a:srgbClr val="22384C"/>
+                </a:solidFill>
+                <a:latin typeface="Georgia" pitchFamily="34" charset="0"/>
+                <a:ea typeface="Georgia" pitchFamily="34" charset="-122"/>
+                <a:cs typeface="Georgia" pitchFamily="34" charset="-120"/>
+              </a:rPr>
+              <a:t>$25</a:t>
+            </a:r>
+            <a:endParaRPr lang="en-US" sz="4000" dirty="0"/>
+          </a:p>
+        </p:txBody>
+      </p:sp>
+      <p:sp>
+        <p:nvSpPr>
+          <p:cNvPr id="22" name="Text 20"/>
+          <p:cNvSpPr/>
+          <p:nvPr/>
+        </p:nvSpPr>
+        <p:spPr>
+          <a:xfrm>
+            <a:off x="8321040" y="3127248"/>
+            <a:ext cx="3054096" cy="292608"/>
+          </a:xfrm>
+          <a:prstGeom prst="rect">
+            <a:avLst/>
+          </a:prstGeom>
+          <a:noFill/>
+          <a:ln/>
+        </p:spPr>
+        <p:txBody>
+          <a:bodyPr wrap="square" lIns="0" tIns="0" rIns="0" bIns="0" rtlCol="0" anchor="ctr"/>
+          <a:lstStyle/>
+          <a:p>
+            <a:pPr indent="0" marL="0">
+              <a:buNone/>
+            </a:pPr>
+            <a:r>
+              <a:rPr lang="en-US" sz="1350" dirty="0">
+                <a:solidFill>
+                  <a:srgbClr val="22384C"/>
+                </a:solidFill>
+                <a:latin typeface="Calibri" pitchFamily="34" charset="0"/>
+                <a:ea typeface="Calibri" pitchFamily="34" charset="-122"/>
+                <a:cs typeface="Calibri" pitchFamily="34" charset="-120"/>
+              </a:rPr>
+              <a:t>a year, to run it</a:t>
+            </a:r>
+            <a:endParaRPr lang="en-US" sz="1350" dirty="0"/>
+          </a:p>
+        </p:txBody>
+      </p:sp>
+      <p:sp>
+        <p:nvSpPr>
+          <p:cNvPr id="23" name="Text 21"/>
+          <p:cNvSpPr/>
+          <p:nvPr/>
+        </p:nvSpPr>
+        <p:spPr>
+          <a:xfrm>
+            <a:off x="8321040" y="3456432"/>
+            <a:ext cx="3054096" cy="457200"/>
+          </a:xfrm>
+          <a:prstGeom prst="rect">
+            <a:avLst/>
+          </a:prstGeom>
+          <a:noFill/>
+          <a:ln/>
+        </p:spPr>
+        <p:txBody>
+          <a:bodyPr wrap="square" lIns="0" tIns="0" rIns="0" bIns="0" rtlCol="0" anchor="ctr"/>
+          <a:lstStyle/>
+          <a:p>
+            <a:pPr indent="0" marL="0">
+              <a:lnSpc>
+                <a:spcPts val="1400"/>
+              </a:lnSpc>
+              <a:buNone/>
+            </a:pPr>
+            <a:r>
+              <a:rPr lang="en-US" sz="1050" dirty="0">
+                <a:solidFill>
+                  <a:srgbClr val="5A7186"/>
+                </a:solidFill>
+                <a:latin typeface="Calibri" pitchFamily="34" charset="0"/>
+                <a:ea typeface="Calibri" pitchFamily="34" charset="-122"/>
+                <a:cs typeface="Calibri" pitchFamily="34" charset="-120"/>
+              </a:rPr>
+              <a:t>Two wakings a day, about 6,500 tokens each. Measured from the real tool output.</a:t>
+            </a:r>
+            <a:endParaRPr lang="en-US" sz="1050" dirty="0"/>
+          </a:p>
+        </p:txBody>
+      </p:sp>
+      <p:sp>
+        <p:nvSpPr>
+          <p:cNvPr id="24" name="Shape 22"/>
+          <p:cNvSpPr/>
+          <p:nvPr/>
+        </p:nvSpPr>
+        <p:spPr>
+          <a:xfrm>
+            <a:off x="566928" y="4334256"/>
+            <a:ext cx="11064240" cy="1188720"/>
+          </a:xfrm>
+          <a:prstGeom prst="roundRect">
+            <a:avLst>
+              <a:gd name="adj" fmla="val 7692"/>
+            </a:avLst>
+          </a:prstGeom>
+          <a:solidFill>
+            <a:srgbClr val="E7EFF7"/>
+          </a:solidFill>
+          <a:ln/>
+        </p:spPr>
+      </p:sp>
+      <p:sp>
+        <p:nvSpPr>
+          <p:cNvPr id="25" name="Text 23"/>
+          <p:cNvSpPr/>
+          <p:nvPr/>
+        </p:nvSpPr>
+        <p:spPr>
+          <a:xfrm>
+            <a:off x="914400" y="4480560"/>
+            <a:ext cx="10424160" cy="365760"/>
+          </a:xfrm>
+          <a:prstGeom prst="rect">
+            <a:avLst/>
+          </a:prstGeom>
+          <a:noFill/>
+          <a:ln/>
+        </p:spPr>
+        <p:txBody>
+          <a:bodyPr wrap="square" lIns="0" tIns="0" rIns="0" bIns="0" rtlCol="0" anchor="ctr"/>
+          <a:lstStyle/>
+          <a:p>
+            <a:pPr indent="0" marL="0">
+              <a:buNone/>
+            </a:pPr>
+            <a:r>
+              <a:rPr lang="en-US" sz="1400" dirty="0">
+                <a:solidFill>
+                  <a:srgbClr val="22384C"/>
+                </a:solidFill>
+                <a:latin typeface="Calibri" pitchFamily="34" charset="0"/>
+                <a:ea typeface="Calibri" pitchFamily="34" charset="-122"/>
+                <a:cs typeface="Calibri" pitchFamily="34" charset="-120"/>
+              </a:rPr>
+              <a:t>Lost sales down 56%. Waste goes up a little, and that is correct: it buys availability with flour.</a:t>
+            </a:r>
+            <a:endParaRPr lang="en-US" sz="1400" dirty="0"/>
+          </a:p>
+        </p:txBody>
+      </p:sp>
+      <p:sp>
+        <p:nvSpPr>
+          <p:cNvPr id="26" name="Text 24"/>
+          <p:cNvSpPr/>
+          <p:nvPr/>
+        </p:nvSpPr>
+        <p:spPr>
+          <a:xfrm>
+            <a:off x="914400" y="4901184"/>
+            <a:ext cx="10424160" cy="365760"/>
+          </a:xfrm>
+          <a:prstGeom prst="rect">
+            <a:avLst/>
+          </a:prstGeom>
+          <a:noFill/>
+          <a:ln/>
+        </p:spPr>
+        <p:txBody>
+          <a:bodyPr wrap="square" lIns="0" tIns="0" rIns="0" bIns="0" rtlCol="0" anchor="ctr"/>
+          <a:lstStyle/>
+          <a:p>
+            <a:pPr indent="0" marL="0">
+              <a:buNone/>
+            </a:pPr>
+            <a:r>
+              <a:rPr lang="en-US" sz="1400" dirty="0">
+                <a:solidFill>
+                  <a:srgbClr val="22384C"/>
+                </a:solidFill>
+                <a:latin typeface="Calibri" pitchFamily="34" charset="0"/>
+                <a:ea typeface="Calibri" pitchFamily="34" charset="-122"/>
+                <a:cs typeface="Calibri" pitchFamily="34" charset="-120"/>
+              </a:rPr>
+              <a:t>Better than the current method on 65 days out of 120. The calculation that never got done now happens every night.</a:t>
+            </a:r>
+            <a:endParaRPr lang="en-US" sz="1400" dirty="0"/>
+          </a:p>
+        </p:txBody>
+      </p:sp>
+      <p:sp>
+        <p:nvSpPr>
+          <p:cNvPr id="27" name="Shape 25"/>
+          <p:cNvSpPr/>
+          <p:nvPr/>
+        </p:nvSpPr>
+        <p:spPr>
+          <a:xfrm>
+            <a:off x="566928" y="5724144"/>
+            <a:ext cx="11064240" cy="859536"/>
+          </a:xfrm>
+          <a:prstGeom prst="roundRect">
+            <a:avLst>
+              <a:gd name="adj" fmla="val 10638"/>
+            </a:avLst>
+          </a:prstGeom>
+          <a:solidFill>
+            <a:srgbClr val="22384C"/>
+          </a:solidFill>
+          <a:ln/>
+        </p:spPr>
+      </p:sp>
+      <p:sp>
+        <p:nvSpPr>
+          <p:cNvPr id="28" name="Text 26"/>
+          <p:cNvSpPr/>
+          <p:nvPr/>
+        </p:nvSpPr>
+        <p:spPr>
+          <a:xfrm>
+            <a:off x="566928" y="5724144"/>
+            <a:ext cx="11064240" cy="859536"/>
+          </a:xfrm>
+          <a:prstGeom prst="rect">
+            <a:avLst/>
+          </a:prstGeom>
+          <a:noFill/>
+          <a:ln/>
+        </p:spPr>
+        <p:txBody>
+          <a:bodyPr wrap="square" lIns="0" tIns="0" rIns="0" bIns="0" rtlCol="0" anchor="ctr"/>
+          <a:lstStyle/>
+          <a:p>
+            <a:pPr algn="ctr" indent="0" marL="0">
+              <a:buNone/>
+            </a:pPr>
+            <a:r>
+              <a:rPr lang="en-US" sz="2200" b="1" dirty="0">
+                <a:solidFill>
+                  <a:srgbClr val="FFFFFF"/>
+                </a:solidFill>
+                <a:latin typeface="Georgia" pitchFamily="34" charset="0"/>
+                <a:ea typeface="Georgia" pitchFamily="34" charset="-122"/>
+                <a:cs typeface="Georgia" pitchFamily="34" charset="-120"/>
+              </a:rPr>
+              <a:t>Five thousand euros back, for twenty-five dollars of arithmetic.</a:t>
+            </a:r>
+            <a:endParaRPr lang="en-US" sz="2200" dirty="0"/>
+          </a:p>
+        </p:txBody>
+      </p:sp>
+    </p:spTree>
+  </p:cSld>
+  <p:clrMapOvr>
+    <a:masterClrMapping/>
+  </p:clrMapOvr>
+</p:sld>
+</file>
+
+<file path=ppt/slides/slide11.xml><?xml version="1.0" encoding="utf-8"?>
+<p:sld xmlns:a="http://schemas.openxmlformats.org/drawingml/2006/main" xmlns:r="http://schemas.openxmlformats.org/officeDocument/2006/relationships" xmlns:p="http://schemas.openxmlformats.org/presentationml/2006/main">
+  <p:cSld name="Slide 11">
+    <p:bg>
+      <p:bgPr>
+        <a:solidFill>
           <a:srgbClr val="22384C"/>
         </a:solidFill>
       </p:bgPr>
@@ -6803,7 +7840,7 @@
                 <a:ea typeface="Calibri" pitchFamily="34" charset="-122"/>
                 <a:cs typeface="Calibri" pitchFamily="34" charset="-120"/>
               </a:rPr>
-              <a:t>THE STACK</a:t>
+              <a:t>THE ARCHITECTURE</a:t>
             </a:r>
             <a:endParaRPr lang="en-US" sz="1100" dirty="0"/>
           </a:p>
@@ -6842,7 +7879,7 @@
                 <a:ea typeface="Georgia" pitchFamily="34" charset="-122"/>
                 <a:cs typeface="Georgia" pitchFamily="34" charset="-120"/>
               </a:rPr>
-              <a:t>What it runs on</a:t>
+              <a:t>How it holds together</a:t>
             </a:r>
             <a:endParaRPr lang="en-US" sz="3600" dirty="0"/>
           </a:p>
@@ -6850,30 +7887,57 @@
       </p:sp>
       <p:sp>
         <p:nvSpPr>
-          <p:cNvPr id="6" name="Text 4"/>
-          <p:cNvSpPr/>
-          <p:nvPr/>
-        </p:nvSpPr>
-        <p:spPr>
-          <a:xfrm>
-            <a:off x="566928" y="1883664"/>
-            <a:ext cx="5303520" cy="274320"/>
-          </a:xfrm>
-          <a:prstGeom prst="rect">
-            <a:avLst/>
-          </a:prstGeom>
-          <a:noFill/>
-          <a:ln/>
-        </p:spPr>
-        <p:txBody>
-          <a:bodyPr wrap="square" lIns="0" tIns="0" rIns="0" bIns="0" rtlCol="0" anchor="ctr"/>
-          <a:lstStyle/>
-          <a:p>
-            <a:pPr indent="0" marL="0">
-              <a:buNone/>
-            </a:pPr>
-            <a:r>
-              <a:rPr lang="en-US" sz="1200" b="1" spc="200" kern="0" dirty="0">
+          <p:cNvPr id="6" name="Shape 4"/>
+          <p:cNvSpPr/>
+          <p:nvPr/>
+        </p:nvSpPr>
+        <p:spPr>
+          <a:xfrm>
+            <a:off x="566928" y="1792224"/>
+            <a:ext cx="3200400" cy="3200400"/>
+          </a:xfrm>
+          <a:prstGeom prst="roundRect">
+            <a:avLst>
+              <a:gd name="adj" fmla="val 2286"/>
+            </a:avLst>
+          </a:prstGeom>
+          <a:solidFill>
+            <a:srgbClr val="E7EFF7"/>
+          </a:solidFill>
+          <a:ln w="12700">
+            <a:solidFill>
+              <a:srgbClr val="DCE6EF"/>
+            </a:solidFill>
+            <a:prstDash val="solid"/>
+          </a:ln>
+        </p:spPr>
+      </p:sp>
+      <p:sp>
+        <p:nvSpPr>
+          <p:cNvPr id="7" name="Text 5"/>
+          <p:cNvSpPr/>
+          <p:nvPr/>
+        </p:nvSpPr>
+        <p:spPr>
+          <a:xfrm>
+            <a:off x="768096" y="1901952"/>
+            <a:ext cx="2798064" cy="274320"/>
+          </a:xfrm>
+          <a:prstGeom prst="rect">
+            <a:avLst/>
+          </a:prstGeom>
+          <a:noFill/>
+          <a:ln/>
+        </p:spPr>
+        <p:txBody>
+          <a:bodyPr wrap="square" lIns="0" tIns="0" rIns="0" bIns="0" rtlCol="0" anchor="ctr"/>
+          <a:lstStyle/>
+          <a:p>
+            <a:pPr indent="0" marL="0">
+              <a:buNone/>
+            </a:pPr>
+            <a:r>
+              <a:rPr lang="en-US" sz="1100" b="1" spc="160" kern="0" dirty="0">
                 <a:solidFill>
                   <a:srgbClr val="3276B1"/>
                 </a:solidFill>
@@ -6881,58 +7945,65 @@
                 <a:ea typeface="Calibri" pitchFamily="34" charset="-122"/>
                 <a:cs typeface="Calibri" pitchFamily="34" charset="-120"/>
               </a:rPr>
-              <a:t>RUNNING</a:t>
-            </a:r>
-            <a:endParaRPr lang="en-US" sz="1200" dirty="0"/>
-          </a:p>
-        </p:txBody>
-      </p:sp>
-      <p:sp>
-        <p:nvSpPr>
-          <p:cNvPr id="7" name="Shape 5"/>
-          <p:cNvSpPr/>
-          <p:nvPr/>
-        </p:nvSpPr>
-        <p:spPr>
-          <a:xfrm>
-            <a:off x="566928" y="2359152"/>
-            <a:ext cx="274320" cy="274320"/>
-          </a:xfrm>
-          <a:prstGeom prst="ellipse">
-            <a:avLst/>
+              <a:t>THE SHOP</a:t>
+            </a:r>
+            <a:endParaRPr lang="en-US" sz="1100" dirty="0"/>
+          </a:p>
+        </p:txBody>
+      </p:sp>
+      <p:sp>
+        <p:nvSpPr>
+          <p:cNvPr id="8" name="Shape 6"/>
+          <p:cNvSpPr/>
+          <p:nvPr/>
+        </p:nvSpPr>
+        <p:spPr>
+          <a:xfrm>
+            <a:off x="786384" y="2286000"/>
+            <a:ext cx="2743200" cy="676656"/>
+          </a:xfrm>
+          <a:prstGeom prst="roundRect">
+            <a:avLst>
+              <a:gd name="adj" fmla="val 8108"/>
+            </a:avLst>
           </a:prstGeom>
           <a:solidFill>
-            <a:srgbClr val="5B9BD1"/>
+            <a:srgbClr val="FFFFFF"/>
           </a:solidFill>
-          <a:ln/>
-        </p:spPr>
-      </p:sp>
-      <p:sp>
-        <p:nvSpPr>
-          <p:cNvPr id="8" name="Text 6"/>
-          <p:cNvSpPr/>
-          <p:nvPr/>
-        </p:nvSpPr>
-        <p:spPr>
-          <a:xfrm>
-            <a:off x="987552" y="2304288"/>
-            <a:ext cx="4846320" cy="329184"/>
-          </a:xfrm>
-          <a:prstGeom prst="rect">
-            <a:avLst/>
-          </a:prstGeom>
-          <a:noFill/>
-          <a:ln/>
-        </p:spPr>
-        <p:txBody>
-          <a:bodyPr wrap="square" lIns="0" tIns="0" rIns="0" bIns="0" rtlCol="0" anchor="ctr"/>
-          <a:lstStyle/>
-          <a:p>
-            <a:pPr indent="0" marL="0">
-              <a:buNone/>
-            </a:pPr>
-            <a:r>
-              <a:rPr lang="en-US" sz="1550" b="1" dirty="0">
+          <a:ln w="12700">
+            <a:solidFill>
+              <a:srgbClr val="DCE6EF"/>
+            </a:solidFill>
+            <a:prstDash val="solid"/>
+          </a:ln>
+        </p:spPr>
+      </p:sp>
+      <p:sp>
+        <p:nvSpPr>
+          <p:cNvPr id="9" name="Text 7"/>
+          <p:cNvSpPr/>
+          <p:nvPr/>
+        </p:nvSpPr>
+        <p:spPr>
+          <a:xfrm>
+            <a:off x="914400" y="2350008"/>
+            <a:ext cx="2468880" cy="256032"/>
+          </a:xfrm>
+          <a:prstGeom prst="rect">
+            <a:avLst/>
+          </a:prstGeom>
+          <a:noFill/>
+          <a:ln/>
+        </p:spPr>
+        <p:txBody>
+          <a:bodyPr wrap="square" lIns="0" tIns="0" rIns="0" bIns="0" rtlCol="0" anchor="ctr"/>
+          <a:lstStyle/>
+          <a:p>
+            <a:pPr indent="0" marL="0">
+              <a:buNone/>
+            </a:pPr>
+            <a:r>
+              <a:rPr lang="en-US" sz="1250" b="1" dirty="0">
                 <a:solidFill>
                   <a:srgbClr val="22384C"/>
                 </a:solidFill>
@@ -6940,41 +8011,38 @@
                 <a:ea typeface="Calibri" pitchFamily="34" charset="-122"/>
                 <a:cs typeface="Calibri" pitchFamily="34" charset="-120"/>
               </a:rPr>
-              <a:t>Strands Agents SDK</a:t>
-            </a:r>
-            <a:endParaRPr lang="en-US" sz="1550" dirty="0"/>
-          </a:p>
-        </p:txBody>
-      </p:sp>
-      <p:sp>
-        <p:nvSpPr>
-          <p:cNvPr id="9" name="Text 7"/>
-          <p:cNvSpPr/>
-          <p:nvPr/>
-        </p:nvSpPr>
-        <p:spPr>
-          <a:xfrm>
-            <a:off x="987552" y="2633472"/>
-            <a:ext cx="4846320" cy="475488"/>
-          </a:xfrm>
-          <a:prstGeom prst="rect">
-            <a:avLst/>
-          </a:prstGeom>
-          <a:noFill/>
-          <a:ln/>
-        </p:spPr>
-        <p:txBody>
-          <a:bodyPr wrap="square" lIns="0" tIns="0" rIns="0" bIns="0" rtlCol="0" anchor="ctr"/>
-          <a:lstStyle/>
-          <a:p>
-            <a:pPr indent="0" marL="0">
-              <a:lnSpc>
-                <a:spcPts val="1700"/>
-              </a:lnSpc>
-              <a:buNone/>
-            </a:pPr>
-            <a:r>
-              <a:rPr lang="en-US" sz="1250" dirty="0">
+              <a:t>The till</a:t>
+            </a:r>
+            <a:endParaRPr lang="en-US" sz="1250" dirty="0"/>
+          </a:p>
+        </p:txBody>
+      </p:sp>
+      <p:sp>
+        <p:nvSpPr>
+          <p:cNvPr id="10" name="Text 8"/>
+          <p:cNvSpPr/>
+          <p:nvPr/>
+        </p:nvSpPr>
+        <p:spPr>
+          <a:xfrm>
+            <a:off x="914400" y="2606040"/>
+            <a:ext cx="2468880" cy="256032"/>
+          </a:xfrm>
+          <a:prstGeom prst="rect">
+            <a:avLst/>
+          </a:prstGeom>
+          <a:noFill/>
+          <a:ln/>
+        </p:spPr>
+        <p:txBody>
+          <a:bodyPr wrap="square" lIns="0" tIns="0" rIns="0" bIns="0" rtlCol="0" anchor="ctr"/>
+          <a:lstStyle/>
+          <a:p>
+            <a:pPr indent="0" marL="0">
+              <a:buNone/>
+            </a:pPr>
+            <a:r>
+              <a:rPr lang="en-US" sz="1050" dirty="0">
                 <a:solidFill>
                   <a:srgbClr val="5A7186"/>
                 </a:solidFill>
@@ -6982,58 +8050,65 @@
                 <a:ea typeface="Calibri" pitchFamily="34" charset="-122"/>
                 <a:cs typeface="Calibri" pitchFamily="34" charset="-120"/>
               </a:rPr>
-              <a:t>One Agent, 16 tools, one hook</a:t>
-            </a:r>
-            <a:endParaRPr lang="en-US" sz="1250" dirty="0"/>
-          </a:p>
-        </p:txBody>
-      </p:sp>
-      <p:sp>
-        <p:nvSpPr>
-          <p:cNvPr id="10" name="Shape 8"/>
-          <p:cNvSpPr/>
-          <p:nvPr/>
-        </p:nvSpPr>
-        <p:spPr>
-          <a:xfrm>
-            <a:off x="566928" y="3328416"/>
-            <a:ext cx="274320" cy="274320"/>
-          </a:xfrm>
-          <a:prstGeom prst="ellipse">
-            <a:avLst/>
+              <a:t>one line per sale</a:t>
+            </a:r>
+            <a:endParaRPr lang="en-US" sz="1050" dirty="0"/>
+          </a:p>
+        </p:txBody>
+      </p:sp>
+      <p:sp>
+        <p:nvSpPr>
+          <p:cNvPr id="11" name="Shape 9"/>
+          <p:cNvSpPr/>
+          <p:nvPr/>
+        </p:nvSpPr>
+        <p:spPr>
+          <a:xfrm>
+            <a:off x="786384" y="3145536"/>
+            <a:ext cx="2743200" cy="676656"/>
+          </a:xfrm>
+          <a:prstGeom prst="roundRect">
+            <a:avLst>
+              <a:gd name="adj" fmla="val 8108"/>
+            </a:avLst>
           </a:prstGeom>
           <a:solidFill>
-            <a:srgbClr val="5B9BD1"/>
+            <a:srgbClr val="FFFFFF"/>
           </a:solidFill>
-          <a:ln/>
-        </p:spPr>
-      </p:sp>
-      <p:sp>
-        <p:nvSpPr>
-          <p:cNvPr id="11" name="Text 9"/>
-          <p:cNvSpPr/>
-          <p:nvPr/>
-        </p:nvSpPr>
-        <p:spPr>
-          <a:xfrm>
-            <a:off x="987552" y="3273552"/>
-            <a:ext cx="4846320" cy="329184"/>
-          </a:xfrm>
-          <a:prstGeom prst="rect">
-            <a:avLst/>
-          </a:prstGeom>
-          <a:noFill/>
-          <a:ln/>
-        </p:spPr>
-        <p:txBody>
-          <a:bodyPr wrap="square" lIns="0" tIns="0" rIns="0" bIns="0" rtlCol="0" anchor="ctr"/>
-          <a:lstStyle/>
-          <a:p>
-            <a:pPr indent="0" marL="0">
-              <a:buNone/>
-            </a:pPr>
-            <a:r>
-              <a:rPr lang="en-US" sz="1550" b="1" dirty="0">
+          <a:ln w="12700">
+            <a:solidFill>
+              <a:srgbClr val="DCE6EF"/>
+            </a:solidFill>
+            <a:prstDash val="solid"/>
+          </a:ln>
+        </p:spPr>
+      </p:sp>
+      <p:sp>
+        <p:nvSpPr>
+          <p:cNvPr id="12" name="Text 10"/>
+          <p:cNvSpPr/>
+          <p:nvPr/>
+        </p:nvSpPr>
+        <p:spPr>
+          <a:xfrm>
+            <a:off x="914400" y="3209544"/>
+            <a:ext cx="2468880" cy="256032"/>
+          </a:xfrm>
+          <a:prstGeom prst="rect">
+            <a:avLst/>
+          </a:prstGeom>
+          <a:noFill/>
+          <a:ln/>
+        </p:spPr>
+        <p:txBody>
+          <a:bodyPr wrap="square" lIns="0" tIns="0" rIns="0" bIns="0" rtlCol="0" anchor="ctr"/>
+          <a:lstStyle/>
+          <a:p>
+            <a:pPr indent="0" marL="0">
+              <a:buNone/>
+            </a:pPr>
+            <a:r>
+              <a:rPr lang="en-US" sz="1250" b="1" dirty="0">
                 <a:solidFill>
                   <a:srgbClr val="22384C"/>
                 </a:solidFill>
@@ -7041,41 +8116,38 @@
                 <a:ea typeface="Calibri" pitchFamily="34" charset="-122"/>
                 <a:cs typeface="Calibri" pitchFamily="34" charset="-120"/>
               </a:rPr>
-              <a:t>Amazon Bedrock</a:t>
-            </a:r>
-            <a:endParaRPr lang="en-US" sz="1550" dirty="0"/>
-          </a:p>
-        </p:txBody>
-      </p:sp>
-      <p:sp>
-        <p:nvSpPr>
-          <p:cNvPr id="12" name="Text 10"/>
-          <p:cNvSpPr/>
-          <p:nvPr/>
-        </p:nvSpPr>
-        <p:spPr>
-          <a:xfrm>
-            <a:off x="987552" y="3602736"/>
-            <a:ext cx="4846320" cy="475488"/>
-          </a:xfrm>
-          <a:prstGeom prst="rect">
-            <a:avLst/>
-          </a:prstGeom>
-          <a:noFill/>
-          <a:ln/>
-        </p:spPr>
-        <p:txBody>
-          <a:bodyPr wrap="square" lIns="0" tIns="0" rIns="0" bIns="0" rtlCol="0" anchor="ctr"/>
-          <a:lstStyle/>
-          <a:p>
-            <a:pPr indent="0" marL="0">
-              <a:lnSpc>
-                <a:spcPts val="1700"/>
-              </a:lnSpc>
-              <a:buNone/>
-            </a:pPr>
-            <a:r>
-              <a:rPr lang="en-US" sz="1250" dirty="0">
+              <a:t>The team</a:t>
+            </a:r>
+            <a:endParaRPr lang="en-US" sz="1250" dirty="0"/>
+          </a:p>
+        </p:txBody>
+      </p:sp>
+      <p:sp>
+        <p:nvSpPr>
+          <p:cNvPr id="13" name="Text 11"/>
+          <p:cNvSpPr/>
+          <p:nvPr/>
+        </p:nvSpPr>
+        <p:spPr>
+          <a:xfrm>
+            <a:off x="914400" y="3465576"/>
+            <a:ext cx="2468880" cy="256032"/>
+          </a:xfrm>
+          <a:prstGeom prst="rect">
+            <a:avLst/>
+          </a:prstGeom>
+          <a:noFill/>
+          <a:ln/>
+        </p:spPr>
+        <p:txBody>
+          <a:bodyPr wrap="square" lIns="0" tIns="0" rIns="0" bIns="0" rtlCol="0" anchor="ctr"/>
+          <a:lstStyle/>
+          <a:p>
+            <a:pPr indent="0" marL="0">
+              <a:buNone/>
+            </a:pPr>
+            <a:r>
+              <a:rPr lang="en-US" sz="1050" dirty="0">
                 <a:solidFill>
                   <a:srgbClr val="5A7186"/>
                 </a:solidFill>
@@ -7083,58 +8155,65 @@
                 <a:ea typeface="Calibri" pitchFamily="34" charset="-122"/>
                 <a:cs typeface="Calibri" pitchFamily="34" charset="-120"/>
               </a:rPr>
-              <a:t>Claude, resolved from the environment</a:t>
-            </a:r>
-            <a:endParaRPr lang="en-US" sz="1250" dirty="0"/>
-          </a:p>
-        </p:txBody>
-      </p:sp>
-      <p:sp>
-        <p:nvSpPr>
-          <p:cNvPr id="13" name="Shape 11"/>
-          <p:cNvSpPr/>
-          <p:nvPr/>
-        </p:nvSpPr>
-        <p:spPr>
-          <a:xfrm>
-            <a:off x="566928" y="4297680"/>
-            <a:ext cx="274320" cy="274320"/>
-          </a:xfrm>
-          <a:prstGeom prst="ellipse">
-            <a:avLst/>
+              <a:t>ticks its own jobs</a:t>
+            </a:r>
+            <a:endParaRPr lang="en-US" sz="1050" dirty="0"/>
+          </a:p>
+        </p:txBody>
+      </p:sp>
+      <p:sp>
+        <p:nvSpPr>
+          <p:cNvPr id="14" name="Shape 12"/>
+          <p:cNvSpPr/>
+          <p:nvPr/>
+        </p:nvSpPr>
+        <p:spPr>
+          <a:xfrm>
+            <a:off x="786384" y="4005072"/>
+            <a:ext cx="2743200" cy="676656"/>
+          </a:xfrm>
+          <a:prstGeom prst="roundRect">
+            <a:avLst>
+              <a:gd name="adj" fmla="val 8108"/>
+            </a:avLst>
           </a:prstGeom>
           <a:solidFill>
-            <a:srgbClr val="5B9BD1"/>
+            <a:srgbClr val="FFFFFF"/>
           </a:solidFill>
-          <a:ln/>
-        </p:spPr>
-      </p:sp>
-      <p:sp>
-        <p:nvSpPr>
-          <p:cNvPr id="14" name="Text 12"/>
-          <p:cNvSpPr/>
-          <p:nvPr/>
-        </p:nvSpPr>
-        <p:spPr>
-          <a:xfrm>
-            <a:off x="987552" y="4242816"/>
-            <a:ext cx="4846320" cy="329184"/>
-          </a:xfrm>
-          <a:prstGeom prst="rect">
-            <a:avLst/>
-          </a:prstGeom>
-          <a:noFill/>
-          <a:ln/>
-        </p:spPr>
-        <p:txBody>
-          <a:bodyPr wrap="square" lIns="0" tIns="0" rIns="0" bIns="0" rtlCol="0" anchor="ctr"/>
-          <a:lstStyle/>
-          <a:p>
-            <a:pPr indent="0" marL="0">
-              <a:buNone/>
-            </a:pPr>
-            <a:r>
-              <a:rPr lang="en-US" sz="1550" b="1" dirty="0">
+          <a:ln w="12700">
+            <a:solidFill>
+              <a:srgbClr val="DCE6EF"/>
+            </a:solidFill>
+            <a:prstDash val="solid"/>
+          </a:ln>
+        </p:spPr>
+      </p:sp>
+      <p:sp>
+        <p:nvSpPr>
+          <p:cNvPr id="15" name="Text 13"/>
+          <p:cNvSpPr/>
+          <p:nvPr/>
+        </p:nvSpPr>
+        <p:spPr>
+          <a:xfrm>
+            <a:off x="914400" y="4069080"/>
+            <a:ext cx="2468880" cy="256032"/>
+          </a:xfrm>
+          <a:prstGeom prst="rect">
+            <a:avLst/>
+          </a:prstGeom>
+          <a:noFill/>
+          <a:ln/>
+        </p:spPr>
+        <p:txBody>
+          <a:bodyPr wrap="square" lIns="0" tIns="0" rIns="0" bIns="0" rtlCol="0" anchor="ctr"/>
+          <a:lstStyle/>
+          <a:p>
+            <a:pPr indent="0" marL="0">
+              <a:buNone/>
+            </a:pPr>
+            <a:r>
+              <a:rPr lang="en-US" sz="1250" b="1" dirty="0">
                 <a:solidFill>
                   <a:srgbClr val="22384C"/>
                 </a:solidFill>
@@ -7142,41 +8221,38 @@
                 <a:ea typeface="Calibri" pitchFamily="34" charset="-122"/>
                 <a:cs typeface="Calibri" pitchFamily="34" charset="-120"/>
               </a:rPr>
-              <a:t>Amazon S3</a:t>
-            </a:r>
-            <a:endParaRPr lang="en-US" sz="1550" dirty="0"/>
-          </a:p>
-        </p:txBody>
-      </p:sp>
-      <p:sp>
-        <p:nvSpPr>
-          <p:cNvPr id="15" name="Text 13"/>
-          <p:cNvSpPr/>
-          <p:nvPr/>
-        </p:nvSpPr>
-        <p:spPr>
-          <a:xfrm>
-            <a:off x="987552" y="4572000"/>
-            <a:ext cx="4846320" cy="475488"/>
-          </a:xfrm>
-          <a:prstGeom prst="rect">
-            <a:avLst/>
-          </a:prstGeom>
-          <a:noFill/>
-          <a:ln/>
-        </p:spPr>
-        <p:txBody>
-          <a:bodyPr wrap="square" lIns="0" tIns="0" rIns="0" bIns="0" rtlCol="0" anchor="ctr"/>
-          <a:lstStyle/>
-          <a:p>
-            <a:pPr indent="0" marL="0">
-              <a:lnSpc>
-                <a:spcPts val="1700"/>
-              </a:lnSpc>
-              <a:buNone/>
-            </a:pPr>
-            <a:r>
-              <a:rPr lang="en-US" sz="1250" dirty="0">
+              <a:t>The owner</a:t>
+            </a:r>
+            <a:endParaRPr lang="en-US" sz="1250" dirty="0"/>
+          </a:p>
+        </p:txBody>
+      </p:sp>
+      <p:sp>
+        <p:nvSpPr>
+          <p:cNvPr id="16" name="Text 14"/>
+          <p:cNvSpPr/>
+          <p:nvPr/>
+        </p:nvSpPr>
+        <p:spPr>
+          <a:xfrm>
+            <a:off x="914400" y="4325112"/>
+            <a:ext cx="2468880" cy="256032"/>
+          </a:xfrm>
+          <a:prstGeom prst="rect">
+            <a:avLst/>
+          </a:prstGeom>
+          <a:noFill/>
+          <a:ln/>
+        </p:spPr>
+        <p:txBody>
+          <a:bodyPr wrap="square" lIns="0" tIns="0" rIns="0" bIns="0" rtlCol="0" anchor="ctr"/>
+          <a:lstStyle/>
+          <a:p>
+            <a:pPr indent="0" marL="0">
+              <a:buNone/>
+            </a:pPr>
+            <a:r>
+              <a:rPr lang="en-US" sz="1050" dirty="0">
                 <a:solidFill>
                   <a:srgbClr val="5A7186"/>
                 </a:solidFill>
@@ -7184,38 +8260,65 @@
                 <a:ea typeface="Calibri" pitchFamily="34" charset="-122"/>
                 <a:cs typeface="Calibri" pitchFamily="34" charset="-120"/>
               </a:rPr>
-              <a:t>The till export, read by offset</a:t>
-            </a:r>
-            <a:endParaRPr lang="en-US" sz="1250" dirty="0"/>
-          </a:p>
-        </p:txBody>
-      </p:sp>
-      <p:sp>
-        <p:nvSpPr>
-          <p:cNvPr id="16" name="Text 14"/>
-          <p:cNvSpPr/>
-          <p:nvPr/>
-        </p:nvSpPr>
-        <p:spPr>
-          <a:xfrm>
-            <a:off x="6309360" y="1883664"/>
-            <a:ext cx="5303520" cy="274320"/>
-          </a:xfrm>
-          <a:prstGeom prst="rect">
-            <a:avLst/>
-          </a:prstGeom>
-          <a:noFill/>
-          <a:ln/>
-        </p:spPr>
-        <p:txBody>
-          <a:bodyPr wrap="square" lIns="0" tIns="0" rIns="0" bIns="0" rtlCol="0" anchor="ctr"/>
-          <a:lstStyle/>
-          <a:p>
-            <a:pPr indent="0" marL="0">
-              <a:buNone/>
-            </a:pPr>
-            <a:r>
-              <a:rPr lang="en-US" sz="1200" b="1" spc="200" kern="0" dirty="0">
+              <a:t>briefs it, then asks</a:t>
+            </a:r>
+            <a:endParaRPr lang="en-US" sz="1050" dirty="0"/>
+          </a:p>
+        </p:txBody>
+      </p:sp>
+      <p:sp>
+        <p:nvSpPr>
+          <p:cNvPr id="17" name="Shape 15"/>
+          <p:cNvSpPr/>
+          <p:nvPr/>
+        </p:nvSpPr>
+        <p:spPr>
+          <a:xfrm>
+            <a:off x="4133088" y="1792224"/>
+            <a:ext cx="3931920" cy="3200400"/>
+          </a:xfrm>
+          <a:prstGeom prst="roundRect">
+            <a:avLst>
+              <a:gd name="adj" fmla="val 2286"/>
+            </a:avLst>
+          </a:prstGeom>
+          <a:solidFill>
+            <a:srgbClr val="FBF3E4"/>
+          </a:solidFill>
+          <a:ln w="12700">
+            <a:solidFill>
+              <a:srgbClr val="DCE6EF"/>
+            </a:solidFill>
+            <a:prstDash val="solid"/>
+          </a:ln>
+        </p:spPr>
+      </p:sp>
+      <p:sp>
+        <p:nvSpPr>
+          <p:cNvPr id="18" name="Text 16"/>
+          <p:cNvSpPr/>
+          <p:nvPr/>
+        </p:nvSpPr>
+        <p:spPr>
+          <a:xfrm>
+            <a:off x="4334256" y="1901952"/>
+            <a:ext cx="3529584" cy="274320"/>
+          </a:xfrm>
+          <a:prstGeom prst="rect">
+            <a:avLst/>
+          </a:prstGeom>
+          <a:noFill/>
+          <a:ln/>
+        </p:spPr>
+        <p:txBody>
+          <a:bodyPr wrap="square" lIns="0" tIns="0" rIns="0" bIns="0" rtlCol="0" anchor="ctr"/>
+          <a:lstStyle/>
+          <a:p>
+            <a:pPr indent="0" marL="0">
+              <a:buNone/>
+            </a:pPr>
+            <a:r>
+              <a:rPr lang="en-US" sz="1100" b="1" spc="160" kern="0" dirty="0">
                 <a:solidFill>
                   <a:srgbClr val="3276B1"/>
                 </a:solidFill>
@@ -7223,100 +8326,155 @@
                 <a:ea typeface="Calibri" pitchFamily="34" charset="-122"/>
                 <a:cs typeface="Calibri" pitchFamily="34" charset="-120"/>
               </a:rPr>
-              <a:t>DEPLOYED</a:t>
-            </a:r>
-            <a:endParaRPr lang="en-US" sz="1200" dirty="0"/>
-          </a:p>
-        </p:txBody>
-      </p:sp>
-      <p:sp>
-        <p:nvSpPr>
-          <p:cNvPr id="17" name="Shape 15"/>
-          <p:cNvSpPr/>
-          <p:nvPr/>
-        </p:nvSpPr>
-        <p:spPr>
-          <a:xfrm>
-            <a:off x="6309360" y="2359152"/>
-            <a:ext cx="274320" cy="274320"/>
-          </a:xfrm>
-          <a:prstGeom prst="ellipse">
-            <a:avLst/>
-          </a:prstGeom>
-          <a:solidFill>
-            <a:srgbClr val="5B9BD1"/>
-          </a:solidFill>
-          <a:ln/>
-        </p:spPr>
-      </p:sp>
-      <p:sp>
-        <p:nvSpPr>
-          <p:cNvPr id="18" name="Text 16"/>
-          <p:cNvSpPr/>
-          <p:nvPr/>
-        </p:nvSpPr>
-        <p:spPr>
-          <a:xfrm>
-            <a:off x="6729984" y="2304288"/>
-            <a:ext cx="4846320" cy="329184"/>
-          </a:xfrm>
-          <a:prstGeom prst="rect">
-            <a:avLst/>
-          </a:prstGeom>
-          <a:noFill/>
-          <a:ln/>
-        </p:spPr>
-        <p:txBody>
-          <a:bodyPr wrap="square" lIns="0" tIns="0" rIns="0" bIns="0" rtlCol="0" anchor="ctr"/>
-          <a:lstStyle/>
-          <a:p>
-            <a:pPr indent="0" marL="0">
-              <a:buNone/>
-            </a:pPr>
-            <a:r>
-              <a:rPr lang="en-US" sz="1550" b="1" dirty="0">
+              <a:t>WHAT PERSISTS</a:t>
+            </a:r>
+            <a:endParaRPr lang="en-US" sz="1100" dirty="0"/>
+          </a:p>
+        </p:txBody>
+      </p:sp>
+      <p:sp>
+        <p:nvSpPr>
+          <p:cNvPr id="19" name="Text 17"/>
+          <p:cNvSpPr/>
+          <p:nvPr/>
+        </p:nvSpPr>
+        <p:spPr>
+          <a:xfrm>
+            <a:off x="4352544" y="2267712"/>
+            <a:ext cx="3566160" cy="237744"/>
+          </a:xfrm>
+          <a:prstGeom prst="rect">
+            <a:avLst/>
+          </a:prstGeom>
+          <a:noFill/>
+          <a:ln/>
+        </p:spPr>
+        <p:txBody>
+          <a:bodyPr wrap="square" lIns="0" tIns="0" rIns="0" bIns="0" rtlCol="0" anchor="ctr"/>
+          <a:lstStyle/>
+          <a:p>
+            <a:pPr indent="0" marL="0">
+              <a:buNone/>
+            </a:pPr>
+            <a:r>
+              <a:rPr lang="en-US" sz="1150" b="1" dirty="0">
                 <a:solidFill>
                   <a:srgbClr val="22384C"/>
+                </a:solidFill>
+                <a:latin typeface="Consolas" pitchFamily="34" charset="0"/>
+                <a:ea typeface="Consolas" pitchFamily="34" charset="-122"/>
+                <a:cs typeface="Consolas" pitchFamily="34" charset="-120"/>
+              </a:rPr>
+              <a:t>bills.jsonl</a:t>
+            </a:r>
+            <a:endParaRPr lang="en-US" sz="1150" dirty="0"/>
+          </a:p>
+        </p:txBody>
+      </p:sp>
+      <p:sp>
+        <p:nvSpPr>
+          <p:cNvPr id="20" name="Text 18"/>
+          <p:cNvSpPr/>
+          <p:nvPr/>
+        </p:nvSpPr>
+        <p:spPr>
+          <a:xfrm>
+            <a:off x="4352544" y="2514600"/>
+            <a:ext cx="3566160" cy="237744"/>
+          </a:xfrm>
+          <a:prstGeom prst="rect">
+            <a:avLst/>
+          </a:prstGeom>
+          <a:noFill/>
+          <a:ln/>
+        </p:spPr>
+        <p:txBody>
+          <a:bodyPr wrap="square" lIns="0" tIns="0" rIns="0" bIns="0" rtlCol="0" anchor="ctr"/>
+          <a:lstStyle/>
+          <a:p>
+            <a:pPr indent="0" marL="0">
+              <a:buNone/>
+            </a:pPr>
+            <a:r>
+              <a:rPr lang="en-US" sz="1050" dirty="0">
+                <a:solidFill>
+                  <a:srgbClr val="5A7186"/>
                 </a:solidFill>
                 <a:latin typeface="Calibri" pitchFamily="34" charset="0"/>
                 <a:ea typeface="Calibri" pitchFamily="34" charset="-122"/>
                 <a:cs typeface="Calibri" pitchFamily="34" charset="-120"/>
               </a:rPr>
-              <a:t>EventBridge Scheduler</a:t>
-            </a:r>
-            <a:endParaRPr lang="en-US" sz="1550" dirty="0"/>
-          </a:p>
-        </p:txBody>
-      </p:sp>
-      <p:sp>
-        <p:nvSpPr>
-          <p:cNvPr id="19" name="Text 17"/>
-          <p:cNvSpPr/>
-          <p:nvPr/>
-        </p:nvSpPr>
-        <p:spPr>
-          <a:xfrm>
-            <a:off x="6729984" y="2633472"/>
-            <a:ext cx="4846320" cy="475488"/>
-          </a:xfrm>
-          <a:prstGeom prst="rect">
-            <a:avLst/>
-          </a:prstGeom>
-          <a:noFill/>
-          <a:ln/>
-        </p:spPr>
-        <p:txBody>
-          <a:bodyPr wrap="square" lIns="0" tIns="0" rIns="0" bIns="0" rtlCol="0" anchor="ctr"/>
-          <a:lstStyle/>
-          <a:p>
-            <a:pPr indent="0" marL="0">
-              <a:lnSpc>
-                <a:spcPts val="1700"/>
-              </a:lnSpc>
-              <a:buNone/>
-            </a:pPr>
-            <a:r>
-              <a:rPr lang="en-US" sz="1250" dirty="0">
+              <a:t>S3, append only, never rewritten</a:t>
+            </a:r>
+            <a:endParaRPr lang="en-US" sz="1050" dirty="0"/>
+          </a:p>
+        </p:txBody>
+      </p:sp>
+      <p:sp>
+        <p:nvSpPr>
+          <p:cNvPr id="21" name="Text 19"/>
+          <p:cNvSpPr/>
+          <p:nvPr/>
+        </p:nvSpPr>
+        <p:spPr>
+          <a:xfrm>
+            <a:off x="4352544" y="2907792"/>
+            <a:ext cx="3566160" cy="237744"/>
+          </a:xfrm>
+          <a:prstGeom prst="rect">
+            <a:avLst/>
+          </a:prstGeom>
+          <a:noFill/>
+          <a:ln/>
+        </p:spPr>
+        <p:txBody>
+          <a:bodyPr wrap="square" lIns="0" tIns="0" rIns="0" bIns="0" rtlCol="0" anchor="ctr"/>
+          <a:lstStyle/>
+          <a:p>
+            <a:pPr indent="0" marL="0">
+              <a:buNone/>
+            </a:pPr>
+            <a:r>
+              <a:rPr lang="en-US" sz="1150" b="1" dirty="0">
+                <a:solidFill>
+                  <a:srgbClr val="22384C"/>
+                </a:solidFill>
+                <a:latin typeface="Consolas" pitchFamily="34" charset="0"/>
+                <a:ea typeface="Consolas" pitchFamily="34" charset="-122"/>
+                <a:cs typeface="Consolas" pitchFamily="34" charset="-120"/>
+              </a:rPr>
+              <a:t>corrected history</a:t>
+            </a:r>
+            <a:endParaRPr lang="en-US" sz="1150" dirty="0"/>
+          </a:p>
+        </p:txBody>
+      </p:sp>
+      <p:sp>
+        <p:nvSpPr>
+          <p:cNvPr id="22" name="Text 20"/>
+          <p:cNvSpPr/>
+          <p:nvPr/>
+        </p:nvSpPr>
+        <p:spPr>
+          <a:xfrm>
+            <a:off x="4352544" y="3154680"/>
+            <a:ext cx="3566160" cy="237744"/>
+          </a:xfrm>
+          <a:prstGeom prst="rect">
+            <a:avLst/>
+          </a:prstGeom>
+          <a:noFill/>
+          <a:ln/>
+        </p:spPr>
+        <p:txBody>
+          <a:bodyPr wrap="square" lIns="0" tIns="0" rIns="0" bIns="0" rtlCol="0" anchor="ctr"/>
+          <a:lstStyle/>
+          <a:p>
+            <a:pPr indent="0" marL="0">
+              <a:buNone/>
+            </a:pPr>
+            <a:r>
+              <a:rPr lang="en-US" sz="1050" dirty="0">
                 <a:solidFill>
                   <a:srgbClr val="5A7186"/>
                 </a:solidFill>
@@ -7324,100 +8482,155 @@
                 <a:ea typeface="Calibri" pitchFamily="34" charset="-122"/>
                 <a:cs typeface="Calibri" pitchFamily="34" charset="-120"/>
               </a:rPr>
-              <a:t>One schedule per shop</a:t>
-            </a:r>
-            <a:endParaRPr lang="en-US" sz="1250" dirty="0"/>
-          </a:p>
-        </p:txBody>
-      </p:sp>
-      <p:sp>
-        <p:nvSpPr>
-          <p:cNvPr id="20" name="Shape 18"/>
-          <p:cNvSpPr/>
-          <p:nvPr/>
-        </p:nvSpPr>
-        <p:spPr>
-          <a:xfrm>
-            <a:off x="6309360" y="3328416"/>
-            <a:ext cx="274320" cy="274320"/>
-          </a:xfrm>
-          <a:prstGeom prst="ellipse">
-            <a:avLst/>
-          </a:prstGeom>
-          <a:solidFill>
-            <a:srgbClr val="5B9BD1"/>
-          </a:solidFill>
-          <a:ln/>
-        </p:spPr>
-      </p:sp>
-      <p:sp>
-        <p:nvSpPr>
-          <p:cNvPr id="21" name="Text 19"/>
-          <p:cNvSpPr/>
-          <p:nvPr/>
-        </p:nvSpPr>
-        <p:spPr>
-          <a:xfrm>
-            <a:off x="6729984" y="3273552"/>
-            <a:ext cx="4846320" cy="329184"/>
-          </a:xfrm>
-          <a:prstGeom prst="rect">
-            <a:avLst/>
-          </a:prstGeom>
-          <a:noFill/>
-          <a:ln/>
-        </p:spPr>
-        <p:txBody>
-          <a:bodyPr wrap="square" lIns="0" tIns="0" rIns="0" bIns="0" rtlCol="0" anchor="ctr"/>
-          <a:lstStyle/>
-          <a:p>
-            <a:pPr indent="0" marL="0">
-              <a:buNone/>
-            </a:pPr>
-            <a:r>
-              <a:rPr lang="en-US" sz="1550" b="1" dirty="0">
+              <a:t>cached on the file's mtime</a:t>
+            </a:r>
+            <a:endParaRPr lang="en-US" sz="1050" dirty="0"/>
+          </a:p>
+        </p:txBody>
+      </p:sp>
+      <p:sp>
+        <p:nvSpPr>
+          <p:cNvPr id="23" name="Text 21"/>
+          <p:cNvSpPr/>
+          <p:nvPr/>
+        </p:nvSpPr>
+        <p:spPr>
+          <a:xfrm>
+            <a:off x="4352544" y="3547872"/>
+            <a:ext cx="3566160" cy="237744"/>
+          </a:xfrm>
+          <a:prstGeom prst="rect">
+            <a:avLst/>
+          </a:prstGeom>
+          <a:noFill/>
+          <a:ln/>
+        </p:spPr>
+        <p:txBody>
+          <a:bodyPr wrap="square" lIns="0" tIns="0" rIns="0" bIns="0" rtlCol="0" anchor="ctr"/>
+          <a:lstStyle/>
+          <a:p>
+            <a:pPr indent="0" marL="0">
+              <a:buNone/>
+            </a:pPr>
+            <a:r>
+              <a:rPr lang="en-US" sz="1150" b="1" dirty="0">
                 <a:solidFill>
                   <a:srgbClr val="22384C"/>
+                </a:solidFill>
+                <a:latin typeface="Consolas" pitchFamily="34" charset="0"/>
+                <a:ea typeface="Consolas" pitchFamily="34" charset="-122"/>
+                <a:cs typeface="Consolas" pitchFamily="34" charset="-120"/>
+              </a:rPr>
+              <a:t>notes.md</a:t>
+            </a:r>
+            <a:endParaRPr lang="en-US" sz="1150" dirty="0"/>
+          </a:p>
+        </p:txBody>
+      </p:sp>
+      <p:sp>
+        <p:nvSpPr>
+          <p:cNvPr id="24" name="Text 22"/>
+          <p:cNvSpPr/>
+          <p:nvPr/>
+        </p:nvSpPr>
+        <p:spPr>
+          <a:xfrm>
+            <a:off x="4352544" y="3794760"/>
+            <a:ext cx="3566160" cy="237744"/>
+          </a:xfrm>
+          <a:prstGeom prst="rect">
+            <a:avLst/>
+          </a:prstGeom>
+          <a:noFill/>
+          <a:ln/>
+        </p:spPr>
+        <p:txBody>
+          <a:bodyPr wrap="square" lIns="0" tIns="0" rIns="0" bIns="0" rtlCol="0" anchor="ctr"/>
+          <a:lstStyle/>
+          <a:p>
+            <a:pPr indent="0" marL="0">
+              <a:buNone/>
+            </a:pPr>
+            <a:r>
+              <a:rPr lang="en-US" sz="1050" dirty="0">
+                <a:solidFill>
+                  <a:srgbClr val="5A7186"/>
                 </a:solidFill>
                 <a:latin typeface="Calibri" pitchFamily="34" charset="0"/>
                 <a:ea typeface="Calibri" pitchFamily="34" charset="-122"/>
                 <a:cs typeface="Calibri" pitchFamily="34" charset="-120"/>
               </a:rPr>
-              <a:t>AgentCore Runtime</a:t>
-            </a:r>
-            <a:endParaRPr lang="en-US" sz="1550" dirty="0"/>
-          </a:p>
-        </p:txBody>
-      </p:sp>
-      <p:sp>
-        <p:nvSpPr>
-          <p:cNvPr id="22" name="Text 20"/>
-          <p:cNvSpPr/>
-          <p:nvPr/>
-        </p:nvSpPr>
-        <p:spPr>
-          <a:xfrm>
-            <a:off x="6729984" y="3602736"/>
-            <a:ext cx="4846320" cy="475488"/>
-          </a:xfrm>
-          <a:prstGeom prst="rect">
-            <a:avLst/>
-          </a:prstGeom>
-          <a:noFill/>
-          <a:ln/>
-        </p:spPr>
-        <p:txBody>
-          <a:bodyPr wrap="square" lIns="0" tIns="0" rIns="0" bIns="0" rtlCol="0" anchor="ctr"/>
-          <a:lstStyle/>
-          <a:p>
-            <a:pPr indent="0" marL="0">
-              <a:lnSpc>
-                <a:spcPts val="1700"/>
-              </a:lnSpc>
-              <a:buNone/>
-            </a:pPr>
-            <a:r>
-              <a:rPr lang="en-US" sz="1250" dirty="0">
+              <a:t>what it learned, owner-editable</a:t>
+            </a:r>
+            <a:endParaRPr lang="en-US" sz="1050" dirty="0"/>
+          </a:p>
+        </p:txBody>
+      </p:sp>
+      <p:sp>
+        <p:nvSpPr>
+          <p:cNvPr id="25" name="Text 23"/>
+          <p:cNvSpPr/>
+          <p:nvPr/>
+        </p:nvSpPr>
+        <p:spPr>
+          <a:xfrm>
+            <a:off x="4352544" y="4187952"/>
+            <a:ext cx="3566160" cy="237744"/>
+          </a:xfrm>
+          <a:prstGeom prst="rect">
+            <a:avLst/>
+          </a:prstGeom>
+          <a:noFill/>
+          <a:ln/>
+        </p:spPr>
+        <p:txBody>
+          <a:bodyPr wrap="square" lIns="0" tIns="0" rIns="0" bIns="0" rtlCol="0" anchor="ctr"/>
+          <a:lstStyle/>
+          <a:p>
+            <a:pPr indent="0" marL="0">
+              <a:buNone/>
+            </a:pPr>
+            <a:r>
+              <a:rPr lang="en-US" sz="1150" b="1" dirty="0">
+                <a:solidFill>
+                  <a:srgbClr val="22384C"/>
+                </a:solidFill>
+                <a:latin typeface="Consolas" pitchFamily="34" charset="0"/>
+                <a:ea typeface="Consolas" pitchFamily="34" charset="-122"/>
+                <a:cs typeface="Consolas" pitchFamily="34" charset="-120"/>
+              </a:rPr>
+              <a:t>journal, tickets</a:t>
+            </a:r>
+            <a:endParaRPr lang="en-US" sz="1150" dirty="0"/>
+          </a:p>
+        </p:txBody>
+      </p:sp>
+      <p:sp>
+        <p:nvSpPr>
+          <p:cNvPr id="26" name="Text 24"/>
+          <p:cNvSpPr/>
+          <p:nvPr/>
+        </p:nvSpPr>
+        <p:spPr>
+          <a:xfrm>
+            <a:off x="4352544" y="4434840"/>
+            <a:ext cx="3566160" cy="237744"/>
+          </a:xfrm>
+          <a:prstGeom prst="rect">
+            <a:avLst/>
+          </a:prstGeom>
+          <a:noFill/>
+          <a:ln/>
+        </p:spPr>
+        <p:txBody>
+          <a:bodyPr wrap="square" lIns="0" tIns="0" rIns="0" bIns="0" rtlCol="0" anchor="ctr"/>
+          <a:lstStyle/>
+          <a:p>
+            <a:pPr indent="0" marL="0">
+              <a:buNone/>
+            </a:pPr>
+            <a:r>
+              <a:rPr lang="en-US" sz="1050" dirty="0">
                 <a:solidFill>
                   <a:srgbClr val="5A7186"/>
                 </a:solidFill>
@@ -7425,127 +8638,618 @@
                 <a:ea typeface="Calibri" pitchFamily="34" charset="-122"/>
                 <a:cs typeface="Calibri" pitchFamily="34" charset="-120"/>
               </a:rPr>
-              <a:t>One session per bakery</a:t>
-            </a:r>
-            <a:endParaRPr lang="en-US" sz="1250" dirty="0"/>
-          </a:p>
-        </p:txBody>
-      </p:sp>
-      <p:sp>
-        <p:nvSpPr>
-          <p:cNvPr id="23" name="Shape 21"/>
-          <p:cNvSpPr/>
-          <p:nvPr/>
-        </p:nvSpPr>
-        <p:spPr>
-          <a:xfrm>
-            <a:off x="6309360" y="4297680"/>
-            <a:ext cx="274320" cy="274320"/>
-          </a:xfrm>
-          <a:prstGeom prst="ellipse">
-            <a:avLst/>
+              <a:t>what it did, what got ticked</a:t>
+            </a:r>
+            <a:endParaRPr lang="en-US" sz="1050" dirty="0"/>
+          </a:p>
+        </p:txBody>
+      </p:sp>
+      <p:sp>
+        <p:nvSpPr>
+          <p:cNvPr id="27" name="Shape 25"/>
+          <p:cNvSpPr/>
+          <p:nvPr/>
+        </p:nvSpPr>
+        <p:spPr>
+          <a:xfrm>
+            <a:off x="8430768" y="1792224"/>
+            <a:ext cx="3200400" cy="3200400"/>
+          </a:xfrm>
+          <a:prstGeom prst="roundRect">
+            <a:avLst>
+              <a:gd name="adj" fmla="val 2286"/>
+            </a:avLst>
           </a:prstGeom>
           <a:solidFill>
-            <a:srgbClr val="5B9BD1"/>
+            <a:srgbClr val="E7EFF7"/>
           </a:solidFill>
-          <a:ln/>
-        </p:spPr>
-      </p:sp>
-      <p:sp>
-        <p:nvSpPr>
-          <p:cNvPr id="24" name="Text 22"/>
-          <p:cNvSpPr/>
-          <p:nvPr/>
-        </p:nvSpPr>
-        <p:spPr>
-          <a:xfrm>
-            <a:off x="6729984" y="4242816"/>
-            <a:ext cx="4846320" cy="329184"/>
-          </a:xfrm>
-          <a:prstGeom prst="rect">
-            <a:avLst/>
-          </a:prstGeom>
-          <a:noFill/>
-          <a:ln/>
-        </p:spPr>
-        <p:txBody>
-          <a:bodyPr wrap="square" lIns="0" tIns="0" rIns="0" bIns="0" rtlCol="0" anchor="ctr"/>
-          <a:lstStyle/>
-          <a:p>
-            <a:pPr indent="0" marL="0">
-              <a:buNone/>
-            </a:pPr>
-            <a:r>
-              <a:rPr lang="en-US" sz="1550" b="1" dirty="0">
-                <a:solidFill>
-                  <a:srgbClr val="22384C"/>
+          <a:ln w="12700">
+            <a:solidFill>
+              <a:srgbClr val="DCE6EF"/>
+            </a:solidFill>
+            <a:prstDash val="solid"/>
+          </a:ln>
+        </p:spPr>
+      </p:sp>
+      <p:sp>
+        <p:nvSpPr>
+          <p:cNvPr id="28" name="Text 26"/>
+          <p:cNvSpPr/>
+          <p:nvPr/>
+        </p:nvSpPr>
+        <p:spPr>
+          <a:xfrm>
+            <a:off x="8631936" y="1901952"/>
+            <a:ext cx="2798064" cy="274320"/>
+          </a:xfrm>
+          <a:prstGeom prst="rect">
+            <a:avLst/>
+          </a:prstGeom>
+          <a:noFill/>
+          <a:ln/>
+        </p:spPr>
+        <p:txBody>
+          <a:bodyPr wrap="square" lIns="0" tIns="0" rIns="0" bIns="0" rtlCol="0" anchor="ctr"/>
+          <a:lstStyle/>
+          <a:p>
+            <a:pPr indent="0" marL="0">
+              <a:buNone/>
+            </a:pPr>
+            <a:r>
+              <a:rPr lang="en-US" sz="1100" b="1" spc="160" kern="0" dirty="0">
+                <a:solidFill>
+                  <a:srgbClr val="3276B1"/>
                 </a:solidFill>
                 <a:latin typeface="Calibri" pitchFamily="34" charset="0"/>
                 <a:ea typeface="Calibri" pitchFamily="34" charset="-122"/>
                 <a:cs typeface="Calibri" pitchFamily="34" charset="-120"/>
               </a:rPr>
-              <a:t>Amazon SES</a:t>
-            </a:r>
-            <a:endParaRPr lang="en-US" sz="1550" dirty="0"/>
-          </a:p>
-        </p:txBody>
-      </p:sp>
-      <p:sp>
-        <p:nvSpPr>
-          <p:cNvPr id="25" name="Text 23"/>
-          <p:cNvSpPr/>
-          <p:nvPr/>
-        </p:nvSpPr>
-        <p:spPr>
-          <a:xfrm>
-            <a:off x="6729984" y="4572000"/>
-            <a:ext cx="4846320" cy="475488"/>
-          </a:xfrm>
-          <a:prstGeom prst="rect">
-            <a:avLst/>
-          </a:prstGeom>
-          <a:noFill/>
-          <a:ln/>
-        </p:spPr>
-        <p:txBody>
-          <a:bodyPr wrap="square" lIns="0" tIns="0" rIns="0" bIns="0" rtlCol="0" anchor="ctr"/>
-          <a:lstStyle/>
-          <a:p>
-            <a:pPr indent="0" marL="0">
-              <a:lnSpc>
-                <a:spcPts val="1700"/>
-              </a:lnSpc>
-              <a:buNone/>
-            </a:pPr>
-            <a:r>
-              <a:rPr lang="en-US" sz="1250" dirty="0">
-                <a:solidFill>
-                  <a:srgbClr val="5A7186"/>
+              <a:t>THE AGENT   ·   STRANDS</a:t>
+            </a:r>
+            <a:endParaRPr lang="en-US" sz="1100" dirty="0"/>
+          </a:p>
+        </p:txBody>
+      </p:sp>
+      <p:sp>
+        <p:nvSpPr>
+          <p:cNvPr id="29" name="Text 27"/>
+          <p:cNvSpPr/>
+          <p:nvPr/>
+        </p:nvSpPr>
+        <p:spPr>
+          <a:xfrm>
+            <a:off x="8650224" y="2267712"/>
+            <a:ext cx="2834640" cy="237744"/>
+          </a:xfrm>
+          <a:prstGeom prst="rect">
+            <a:avLst/>
+          </a:prstGeom>
+          <a:noFill/>
+          <a:ln/>
+        </p:spPr>
+        <p:txBody>
+          <a:bodyPr wrap="square" lIns="0" tIns="0" rIns="0" bIns="0" rtlCol="0" anchor="ctr"/>
+          <a:lstStyle/>
+          <a:p>
+            <a:pPr indent="0" marL="0">
+              <a:buNone/>
+            </a:pPr>
+            <a:r>
+              <a:rPr lang="en-US" sz="1200" b="1" dirty="0">
+                <a:solidFill>
+                  <a:srgbClr val="22384C"/>
                 </a:solidFill>
                 <a:latin typeface="Calibri" pitchFamily="34" charset="0"/>
                 <a:ea typeface="Calibri" pitchFamily="34" charset="-122"/>
                 <a:cs typeface="Calibri" pitchFamily="34" charset="-120"/>
               </a:rPr>
-              <a:t>The one email</a:t>
-            </a:r>
-            <a:endParaRPr lang="en-US" sz="1250" dirty="0"/>
-          </a:p>
-        </p:txBody>
-      </p:sp>
-      <p:sp>
-        <p:nvSpPr>
-          <p:cNvPr id="26" name="Shape 24"/>
-          <p:cNvSpPr/>
-          <p:nvPr/>
-        </p:nvSpPr>
-        <p:spPr>
-          <a:xfrm>
-            <a:off x="566928" y="5285232"/>
-            <a:ext cx="11064240" cy="1115568"/>
+              <a:t>18 tools</a:t>
+            </a:r>
+            <a:endParaRPr lang="en-US" sz="1200" dirty="0"/>
+          </a:p>
+        </p:txBody>
+      </p:sp>
+      <p:sp>
+        <p:nvSpPr>
+          <p:cNvPr id="30" name="Text 28"/>
+          <p:cNvSpPr/>
+          <p:nvPr/>
+        </p:nvSpPr>
+        <p:spPr>
+          <a:xfrm>
+            <a:off x="8650224" y="2496312"/>
+            <a:ext cx="2834640" cy="237744"/>
+          </a:xfrm>
+          <a:prstGeom prst="rect">
+            <a:avLst/>
+          </a:prstGeom>
+          <a:noFill/>
+          <a:ln/>
+        </p:spPr>
+        <p:txBody>
+          <a:bodyPr wrap="square" lIns="0" tIns="0" rIns="0" bIns="0" rtlCol="0" anchor="ctr"/>
+          <a:lstStyle/>
+          <a:p>
+            <a:pPr indent="0" marL="0">
+              <a:buNone/>
+            </a:pPr>
+            <a:r>
+              <a:rPr lang="en-US" sz="1050" dirty="0">
+                <a:solidFill>
+                  <a:srgbClr val="5A7186"/>
+                </a:solidFill>
+                <a:latin typeface="Calibri" pitchFamily="34" charset="0"/>
+                <a:ea typeface="Calibri" pitchFamily="34" charset="-122"/>
+                <a:cs typeface="Calibri" pitchFamily="34" charset="-120"/>
+              </a:rPr>
+              <a:t>5 read  ·  5 compute  ·  3 look ahead</a:t>
+            </a:r>
+            <a:endParaRPr lang="en-US" sz="1050" dirty="0"/>
+          </a:p>
+        </p:txBody>
+      </p:sp>
+      <p:sp>
+        <p:nvSpPr>
+          <p:cNvPr id="31" name="Text 29"/>
+          <p:cNvSpPr/>
+          <p:nvPr/>
+        </p:nvSpPr>
+        <p:spPr>
+          <a:xfrm>
+            <a:off x="8650224" y="2724912"/>
+            <a:ext cx="2834640" cy="237744"/>
+          </a:xfrm>
+          <a:prstGeom prst="rect">
+            <a:avLst/>
+          </a:prstGeom>
+          <a:noFill/>
+          <a:ln/>
+        </p:spPr>
+        <p:txBody>
+          <a:bodyPr wrap="square" lIns="0" tIns="0" rIns="0" bIns="0" rtlCol="0" anchor="ctr"/>
+          <a:lstStyle/>
+          <a:p>
+            <a:pPr indent="0" marL="0">
+              <a:buNone/>
+            </a:pPr>
+            <a:r>
+              <a:rPr lang="en-US" sz="1050" dirty="0">
+                <a:solidFill>
+                  <a:srgbClr val="5A7186"/>
+                </a:solidFill>
+                <a:latin typeface="Calibri" pitchFamily="34" charset="0"/>
+                <a:ea typeface="Calibri" pitchFamily="34" charset="-122"/>
+                <a:cs typeface="Calibri" pitchFamily="34" charset="-120"/>
+              </a:rPr>
+              <a:t>2 memory  ·  1 acts</a:t>
+            </a:r>
+            <a:endParaRPr lang="en-US" sz="1050" dirty="0"/>
+          </a:p>
+        </p:txBody>
+      </p:sp>
+      <p:sp>
+        <p:nvSpPr>
+          <p:cNvPr id="32" name="Text 30"/>
+          <p:cNvSpPr/>
+          <p:nvPr/>
+        </p:nvSpPr>
+        <p:spPr>
+          <a:xfrm>
+            <a:off x="8650224" y="3182112"/>
+            <a:ext cx="2834640" cy="237744"/>
+          </a:xfrm>
+          <a:prstGeom prst="rect">
+            <a:avLst/>
+          </a:prstGeom>
+          <a:noFill/>
+          <a:ln/>
+        </p:spPr>
+        <p:txBody>
+          <a:bodyPr wrap="square" lIns="0" tIns="0" rIns="0" bIns="0" rtlCol="0" anchor="ctr"/>
+          <a:lstStyle/>
+          <a:p>
+            <a:pPr indent="0" marL="0">
+              <a:buNone/>
+            </a:pPr>
+            <a:r>
+              <a:rPr lang="en-US" sz="1200" b="1" dirty="0">
+                <a:solidFill>
+                  <a:srgbClr val="22384C"/>
+                </a:solidFill>
+                <a:latin typeface="Calibri" pitchFamily="34" charset="0"/>
+                <a:ea typeface="Calibri" pitchFamily="34" charset="-122"/>
+                <a:cs typeface="Calibri" pitchFamily="34" charset="-120"/>
+              </a:rPr>
+              <a:t>HookProvider</a:t>
+            </a:r>
+            <a:endParaRPr lang="en-US" sz="1200" dirty="0"/>
+          </a:p>
+        </p:txBody>
+      </p:sp>
+      <p:sp>
+        <p:nvSpPr>
+          <p:cNvPr id="33" name="Text 31"/>
+          <p:cNvSpPr/>
+          <p:nvPr/>
+        </p:nvSpPr>
+        <p:spPr>
+          <a:xfrm>
+            <a:off x="8650224" y="3410712"/>
+            <a:ext cx="2834640" cy="237744"/>
+          </a:xfrm>
+          <a:prstGeom prst="rect">
+            <a:avLst/>
+          </a:prstGeom>
+          <a:noFill/>
+          <a:ln/>
+        </p:spPr>
+        <p:txBody>
+          <a:bodyPr wrap="square" lIns="0" tIns="0" rIns="0" bIns="0" rtlCol="0" anchor="ctr"/>
+          <a:lstStyle/>
+          <a:p>
+            <a:pPr indent="0" marL="0">
+              <a:buNone/>
+            </a:pPr>
+            <a:r>
+              <a:rPr lang="en-US" sz="1050" dirty="0">
+                <a:solidFill>
+                  <a:srgbClr val="5A7186"/>
+                </a:solidFill>
+                <a:latin typeface="Calibri" pitchFamily="34" charset="0"/>
+                <a:ea typeface="Calibri" pitchFamily="34" charset="-122"/>
+                <a:cs typeface="Calibri" pitchFamily="34" charset="-120"/>
+              </a:rPr>
+              <a:t>cancels the run on spend,</a:t>
+            </a:r>
+            <a:endParaRPr lang="en-US" sz="1050" dirty="0"/>
+          </a:p>
+        </p:txBody>
+      </p:sp>
+      <p:sp>
+        <p:nvSpPr>
+          <p:cNvPr id="34" name="Text 32"/>
+          <p:cNvSpPr/>
+          <p:nvPr/>
+        </p:nvSpPr>
+        <p:spPr>
+          <a:xfrm>
+            <a:off x="8650224" y="3639312"/>
+            <a:ext cx="2834640" cy="237744"/>
+          </a:xfrm>
+          <a:prstGeom prst="rect">
+            <a:avLst/>
+          </a:prstGeom>
+          <a:noFill/>
+          <a:ln/>
+        </p:spPr>
+        <p:txBody>
+          <a:bodyPr wrap="square" lIns="0" tIns="0" rIns="0" bIns="0" rtlCol="0" anchor="ctr"/>
+          <a:lstStyle/>
+          <a:p>
+            <a:pPr indent="0" marL="0">
+              <a:buNone/>
+            </a:pPr>
+            <a:r>
+              <a:rPr lang="en-US" sz="1050" dirty="0">
+                <a:solidFill>
+                  <a:srgbClr val="5A7186"/>
+                </a:solidFill>
+                <a:latin typeface="Calibri" pitchFamily="34" charset="0"/>
+                <a:ea typeface="Calibri" pitchFamily="34" charset="-122"/>
+                <a:cs typeface="Calibri" pitchFamily="34" charset="-120"/>
+              </a:rPr>
+              <a:t>looping, or a second action</a:t>
+            </a:r>
+            <a:endParaRPr lang="en-US" sz="1050" dirty="0"/>
+          </a:p>
+        </p:txBody>
+      </p:sp>
+      <p:sp>
+        <p:nvSpPr>
+          <p:cNvPr id="35" name="Text 33"/>
+          <p:cNvSpPr/>
+          <p:nvPr/>
+        </p:nvSpPr>
+        <p:spPr>
+          <a:xfrm>
+            <a:off x="8650224" y="4224528"/>
+            <a:ext cx="2834640" cy="237744"/>
+          </a:xfrm>
+          <a:prstGeom prst="rect">
+            <a:avLst/>
+          </a:prstGeom>
+          <a:noFill/>
+          <a:ln/>
+        </p:spPr>
+        <p:txBody>
+          <a:bodyPr wrap="square" lIns="0" tIns="0" rIns="0" bIns="0" rtlCol="0" anchor="ctr"/>
+          <a:lstStyle/>
+          <a:p>
+            <a:pPr indent="0" marL="0">
+              <a:buNone/>
+            </a:pPr>
+            <a:r>
+              <a:rPr lang="en-US" sz="1200" b="1" dirty="0">
+                <a:solidFill>
+                  <a:srgbClr val="22384C"/>
+                </a:solidFill>
+                <a:latin typeface="Calibri" pitchFamily="34" charset="0"/>
+                <a:ea typeface="Calibri" pitchFamily="34" charset="-122"/>
+                <a:cs typeface="Calibri" pitchFamily="34" charset="-120"/>
+              </a:rPr>
+              <a:t>Amazon Bedrock</a:t>
+            </a:r>
+            <a:endParaRPr lang="en-US" sz="1200" dirty="0"/>
+          </a:p>
+        </p:txBody>
+      </p:sp>
+      <p:sp>
+        <p:nvSpPr>
+          <p:cNvPr id="36" name="Text 34"/>
+          <p:cNvSpPr/>
+          <p:nvPr/>
+        </p:nvSpPr>
+        <p:spPr>
+          <a:xfrm>
+            <a:off x="8650224" y="4462272"/>
+            <a:ext cx="2834640" cy="411480"/>
+          </a:xfrm>
+          <a:prstGeom prst="rect">
+            <a:avLst/>
+          </a:prstGeom>
+          <a:noFill/>
+          <a:ln/>
+        </p:spPr>
+        <p:txBody>
+          <a:bodyPr wrap="square" lIns="0" tIns="0" rIns="0" bIns="0" rtlCol="0" anchor="ctr"/>
+          <a:lstStyle/>
+          <a:p>
+            <a:pPr indent="0" marL="0">
+              <a:lnSpc>
+                <a:spcPts val="1300"/>
+              </a:lnSpc>
+              <a:buNone/>
+            </a:pPr>
+            <a:r>
+              <a:rPr lang="en-US" sz="1050" dirty="0">
+                <a:solidFill>
+                  <a:srgbClr val="5A7186"/>
+                </a:solidFill>
+                <a:latin typeface="Calibri" pitchFamily="34" charset="0"/>
+                <a:ea typeface="Calibri" pitchFamily="34" charset="-122"/>
+                <a:cs typeface="Calibri" pitchFamily="34" charset="-120"/>
+              </a:rPr>
+              <a:t>on AgentCore Runtime,</a:t>
+            </a:r>
+            <a:endParaRPr lang="en-US" sz="1050" dirty="0"/>
+          </a:p>
+          <a:p>
+            <a:pPr indent="0" marL="0">
+              <a:lnSpc>
+                <a:spcPts val="1300"/>
+              </a:lnSpc>
+              <a:buNone/>
+            </a:pPr>
+            <a:r>
+              <a:rPr lang="en-US" sz="1050" dirty="0">
+                <a:solidFill>
+                  <a:srgbClr val="5A7186"/>
+                </a:solidFill>
+                <a:latin typeface="Calibri" pitchFamily="34" charset="0"/>
+                <a:ea typeface="Calibri" pitchFamily="34" charset="-122"/>
+                <a:cs typeface="Calibri" pitchFamily="34" charset="-120"/>
+              </a:rPr>
+              <a:t>one session per bakery</a:t>
+            </a:r>
+            <a:endParaRPr lang="en-US" sz="1050" dirty="0"/>
+          </a:p>
+        </p:txBody>
+      </p:sp>
+      <p:sp>
+        <p:nvSpPr>
+          <p:cNvPr id="37" name="Shape 35"/>
+          <p:cNvSpPr/>
+          <p:nvPr/>
+        </p:nvSpPr>
+        <p:spPr>
+          <a:xfrm>
+            <a:off x="3803904" y="3291840"/>
+            <a:ext cx="192024" cy="0"/>
+          </a:xfrm>
+          <a:prstGeom prst="line">
+            <a:avLst/>
+          </a:prstGeom>
+          <a:noFill/>
+          <a:ln w="19050">
+            <a:solidFill>
+              <a:srgbClr val="8FAAC1"/>
+            </a:solidFill>
+            <a:prstDash val="solid"/>
+          </a:ln>
+        </p:spPr>
+      </p:sp>
+      <p:sp>
+        <p:nvSpPr>
+          <p:cNvPr id="38" name="Shape 36"/>
+          <p:cNvSpPr/>
+          <p:nvPr/>
+        </p:nvSpPr>
+        <p:spPr>
+          <a:xfrm rot="5400000">
+            <a:off x="3977640" y="3227832"/>
+            <a:ext cx="137160" cy="128016"/>
+          </a:xfrm>
+          <a:prstGeom prst="triangle">
+            <a:avLst/>
+          </a:prstGeom>
+          <a:solidFill>
+            <a:srgbClr val="8FAAC1"/>
+          </a:solidFill>
+          <a:ln/>
+        </p:spPr>
+      </p:sp>
+      <p:sp>
+        <p:nvSpPr>
+          <p:cNvPr id="39" name="Shape 37"/>
+          <p:cNvSpPr/>
+          <p:nvPr/>
+        </p:nvSpPr>
+        <p:spPr>
+          <a:xfrm>
+            <a:off x="8101584" y="3291840"/>
+            <a:ext cx="192024" cy="0"/>
+          </a:xfrm>
+          <a:prstGeom prst="line">
+            <a:avLst/>
+          </a:prstGeom>
+          <a:noFill/>
+          <a:ln w="19050">
+            <a:solidFill>
+              <a:srgbClr val="8FAAC1"/>
+            </a:solidFill>
+            <a:prstDash val="solid"/>
+          </a:ln>
+        </p:spPr>
+      </p:sp>
+      <p:sp>
+        <p:nvSpPr>
+          <p:cNvPr id="40" name="Shape 38"/>
+          <p:cNvSpPr/>
+          <p:nvPr/>
+        </p:nvSpPr>
+        <p:spPr>
+          <a:xfrm rot="5400000">
+            <a:off x="8275320" y="3227832"/>
+            <a:ext cx="137160" cy="128016"/>
+          </a:xfrm>
+          <a:prstGeom prst="triangle">
+            <a:avLst/>
+          </a:prstGeom>
+          <a:solidFill>
+            <a:srgbClr val="8FAAC1"/>
+          </a:solidFill>
+          <a:ln/>
+        </p:spPr>
+      </p:sp>
+      <p:sp>
+        <p:nvSpPr>
+          <p:cNvPr id="41" name="Shape 39"/>
+          <p:cNvSpPr/>
+          <p:nvPr/>
+        </p:nvSpPr>
+        <p:spPr>
+          <a:xfrm>
+            <a:off x="786384" y="5212080"/>
+            <a:ext cx="10844784" cy="0"/>
+          </a:xfrm>
+          <a:prstGeom prst="line">
+            <a:avLst/>
+          </a:prstGeom>
+          <a:noFill/>
+          <a:ln w="19050">
+            <a:solidFill>
+              <a:srgbClr val="CD395F"/>
+            </a:solidFill>
+            <a:prstDash val="solid"/>
+          </a:ln>
+        </p:spPr>
+      </p:sp>
+      <p:sp>
+        <p:nvSpPr>
+          <p:cNvPr id="42" name="Shape 40"/>
+          <p:cNvSpPr/>
+          <p:nvPr/>
+        </p:nvSpPr>
+        <p:spPr>
+          <a:xfrm>
+            <a:off x="11631168" y="5029200"/>
+            <a:ext cx="0" cy="182880"/>
+          </a:xfrm>
+          <a:prstGeom prst="line">
+            <a:avLst/>
+          </a:prstGeom>
+          <a:noFill/>
+          <a:ln w="19050">
+            <a:solidFill>
+              <a:srgbClr val="CD395F"/>
+            </a:solidFill>
+            <a:prstDash val="solid"/>
+          </a:ln>
+        </p:spPr>
+      </p:sp>
+      <p:sp>
+        <p:nvSpPr>
+          <p:cNvPr id="43" name="Shape 41"/>
+          <p:cNvSpPr/>
+          <p:nvPr/>
+        </p:nvSpPr>
+        <p:spPr>
+          <a:xfrm rot="16200000">
+            <a:off x="722376" y="5148072"/>
+            <a:ext cx="137160" cy="128016"/>
+          </a:xfrm>
+          <a:prstGeom prst="triangle">
+            <a:avLst/>
+          </a:prstGeom>
+          <a:solidFill>
+            <a:srgbClr val="CD395F"/>
+          </a:solidFill>
+          <a:ln/>
+        </p:spPr>
+      </p:sp>
+      <p:sp>
+        <p:nvSpPr>
+          <p:cNvPr id="44" name="Text 42"/>
+          <p:cNvSpPr/>
+          <p:nvPr/>
+        </p:nvSpPr>
+        <p:spPr>
+          <a:xfrm>
+            <a:off x="786384" y="5285232"/>
+            <a:ext cx="10844784" cy="274320"/>
+          </a:xfrm>
+          <a:prstGeom prst="rect">
+            <a:avLst/>
+          </a:prstGeom>
+          <a:noFill/>
+          <a:ln/>
+        </p:spPr>
+        <p:txBody>
+          <a:bodyPr wrap="square" lIns="0" tIns="0" rIns="0" bIns="0" rtlCol="0" anchor="ctr"/>
+          <a:lstStyle/>
+          <a:p>
+            <a:pPr algn="ctr" indent="0" marL="0">
+              <a:buNone/>
+            </a:pPr>
+            <a:r>
+              <a:rPr lang="en-US" sz="1100" dirty="0">
+                <a:solidFill>
+                  <a:srgbClr val="CD395F"/>
+                </a:solidFill>
+                <a:latin typeface="Calibri" pitchFamily="34" charset="0"/>
+                <a:ea typeface="Calibri" pitchFamily="34" charset="-122"/>
+                <a:cs typeface="Calibri" pitchFamily="34" charset="-120"/>
+              </a:rPr>
+              <a:t>Amazon SES   ·   one email, only when a decision needs a person</a:t>
+            </a:r>
+            <a:endParaRPr lang="en-US" sz="1100" dirty="0"/>
+          </a:p>
+        </p:txBody>
+      </p:sp>
+      <p:sp>
+        <p:nvSpPr>
+          <p:cNvPr id="45" name="Shape 43"/>
+          <p:cNvSpPr/>
+          <p:nvPr/>
+        </p:nvSpPr>
+        <p:spPr>
+          <a:xfrm>
+            <a:off x="566928" y="5724144"/>
+            <a:ext cx="11064240" cy="859536"/>
           </a:xfrm>
           <a:prstGeom prst="roundRect">
             <a:avLst>
-              <a:gd name="adj" fmla="val 8197"/>
+              <a:gd name="adj" fmla="val 10638"/>
             </a:avLst>
           </a:prstGeom>
           <a:solidFill>
@@ -7556,79 +9260,157 @@
       </p:sp>
       <p:sp>
         <p:nvSpPr>
-          <p:cNvPr id="27" name="Text 25"/>
-          <p:cNvSpPr/>
-          <p:nvPr/>
-        </p:nvSpPr>
-        <p:spPr>
-          <a:xfrm>
-            <a:off x="914400" y="5431536"/>
-            <a:ext cx="10424160" cy="365760"/>
-          </a:xfrm>
-          <a:prstGeom prst="rect">
-            <a:avLst/>
-          </a:prstGeom>
-          <a:noFill/>
-          <a:ln/>
-        </p:spPr>
-        <p:txBody>
-          <a:bodyPr wrap="square" lIns="0" tIns="0" rIns="0" bIns="0" rtlCol="0" anchor="ctr"/>
-          <a:lstStyle/>
-          <a:p>
-            <a:pPr indent="0" marL="0">
-              <a:buNone/>
-            </a:pPr>
-            <a:r>
-              <a:rPr lang="en-US" sz="2000" b="1" dirty="0">
-                <a:solidFill>
-                  <a:srgbClr val="FFFFFF"/>
-                </a:solidFill>
-                <a:latin typeface="Georgia" pitchFamily="34" charset="0"/>
-                <a:ea typeface="Georgia" pitchFamily="34" charset="-122"/>
-                <a:cs typeface="Georgia" pitchFamily="34" charset="-120"/>
-              </a:rPr>
-              <a:t>The limits are hooks, not prompt text.</a:t>
-            </a:r>
-            <a:endParaRPr lang="en-US" sz="2000" dirty="0"/>
-          </a:p>
-        </p:txBody>
-      </p:sp>
-      <p:sp>
-        <p:nvSpPr>
-          <p:cNvPr id="28" name="Text 26"/>
-          <p:cNvSpPr/>
-          <p:nvPr/>
-        </p:nvSpPr>
-        <p:spPr>
-          <a:xfrm>
-            <a:off x="914400" y="5852160"/>
-            <a:ext cx="10424160" cy="384048"/>
-          </a:xfrm>
-          <a:prstGeom prst="rect">
-            <a:avLst/>
-          </a:prstGeom>
-          <a:noFill/>
-          <a:ln/>
-        </p:spPr>
-        <p:txBody>
-          <a:bodyPr wrap="square" lIns="0" tIns="0" rIns="0" bIns="0" rtlCol="0" anchor="ctr"/>
-          <a:lstStyle/>
-          <a:p>
-            <a:pPr indent="0" marL="0">
-              <a:buNone/>
-            </a:pPr>
-            <a:r>
-              <a:rPr lang="en-US" sz="1350" dirty="0">
-                <a:solidFill>
-                  <a:srgbClr val="AFCBE3"/>
+          <p:cNvPr id="46" name="Text 44"/>
+          <p:cNvSpPr/>
+          <p:nvPr/>
+        </p:nvSpPr>
+        <p:spPr>
+          <a:xfrm>
+            <a:off x="896112" y="5833872"/>
+            <a:ext cx="2194560" cy="274320"/>
+          </a:xfrm>
+          <a:prstGeom prst="rect">
+            <a:avLst/>
+          </a:prstGeom>
+          <a:noFill/>
+          <a:ln/>
+        </p:spPr>
+        <p:txBody>
+          <a:bodyPr wrap="square" lIns="0" tIns="0" rIns="0" bIns="0" rtlCol="0" anchor="ctr"/>
+          <a:lstStyle/>
+          <a:p>
+            <a:pPr indent="0" marL="0">
+              <a:buNone/>
+            </a:pPr>
+            <a:r>
+              <a:rPr lang="en-US" sz="1250" b="1" dirty="0">
+                <a:solidFill>
+                  <a:srgbClr val="5B9BD1"/>
                 </a:solidFill>
                 <a:latin typeface="Calibri" pitchFamily="34" charset="0"/>
                 <a:ea typeface="Calibri" pitchFamily="34" charset="-122"/>
                 <a:cs typeface="Calibri" pitchFamily="34" charset="-120"/>
               </a:rPr>
-              <a:t>A prompt is a request a model can argue with. A hook cancels the run.</a:t>
-            </a:r>
-            <a:endParaRPr lang="en-US" sz="1350" dirty="0"/>
+              <a:t>All day</a:t>
+            </a:r>
+            <a:endParaRPr lang="en-US" sz="1250" dirty="0"/>
+          </a:p>
+        </p:txBody>
+      </p:sp>
+      <p:sp>
+        <p:nvSpPr>
+          <p:cNvPr id="47" name="Text 45"/>
+          <p:cNvSpPr/>
+          <p:nvPr/>
+        </p:nvSpPr>
+        <p:spPr>
+          <a:xfrm>
+            <a:off x="896112" y="6108192"/>
+            <a:ext cx="5212080" cy="292608"/>
+          </a:xfrm>
+          <a:prstGeom prst="rect">
+            <a:avLst/>
+          </a:prstGeom>
+          <a:noFill/>
+          <a:ln/>
+        </p:spPr>
+        <p:txBody>
+          <a:bodyPr wrap="square" lIns="0" tIns="0" rIns="0" bIns="0" rtlCol="0" anchor="ctr"/>
+          <a:lstStyle/>
+          <a:p>
+            <a:pPr indent="0" marL="0">
+              <a:buNone/>
+            </a:pPr>
+            <a:r>
+              <a:rPr lang="en-US" sz="1100" dirty="0">
+                <a:solidFill>
+                  <a:srgbClr val="AFCBE3"/>
+                </a:solidFill>
+                <a:latin typeface="Calibri" pitchFamily="34" charset="0"/>
+                <a:ea typeface="Calibri" pitchFamily="34" charset="-122"/>
+                <a:cs typeface="Calibri" pitchFamily="34" charset="-120"/>
+              </a:rPr>
+              <a:t>receipts land, the page follows, jobs get ticked, and it can be asked anything</a:t>
+            </a:r>
+            <a:endParaRPr lang="en-US" sz="1100" dirty="0"/>
+          </a:p>
+        </p:txBody>
+      </p:sp>
+      <p:sp>
+        <p:nvSpPr>
+          <p:cNvPr id="48" name="Text 46"/>
+          <p:cNvSpPr/>
+          <p:nvPr/>
+        </p:nvSpPr>
+        <p:spPr>
+          <a:xfrm>
+            <a:off x="6492240" y="5833872"/>
+            <a:ext cx="2194560" cy="274320"/>
+          </a:xfrm>
+          <a:prstGeom prst="rect">
+            <a:avLst/>
+          </a:prstGeom>
+          <a:noFill/>
+          <a:ln/>
+        </p:spPr>
+        <p:txBody>
+          <a:bodyPr wrap="square" lIns="0" tIns="0" rIns="0" bIns="0" rtlCol="0" anchor="ctr"/>
+          <a:lstStyle/>
+          <a:p>
+            <a:pPr indent="0" marL="0">
+              <a:buNone/>
+            </a:pPr>
+            <a:r>
+              <a:rPr lang="en-US" sz="1250" b="1" dirty="0">
+                <a:solidFill>
+                  <a:srgbClr val="E38FA6"/>
+                </a:solidFill>
+                <a:latin typeface="Calibri" pitchFamily="34" charset="0"/>
+                <a:ea typeface="Calibri" pitchFamily="34" charset="-122"/>
+                <a:cs typeface="Calibri" pitchFamily="34" charset="-120"/>
+              </a:rPr>
+              <a:t>At closing</a:t>
+            </a:r>
+            <a:endParaRPr lang="en-US" sz="1250" dirty="0"/>
+          </a:p>
+        </p:txBody>
+      </p:sp>
+      <p:sp>
+        <p:nvSpPr>
+          <p:cNvPr id="49" name="Text 47"/>
+          <p:cNvSpPr/>
+          <p:nvPr/>
+        </p:nvSpPr>
+        <p:spPr>
+          <a:xfrm>
+            <a:off x="6492240" y="6108192"/>
+            <a:ext cx="5029200" cy="292608"/>
+          </a:xfrm>
+          <a:prstGeom prst="rect">
+            <a:avLst/>
+          </a:prstGeom>
+          <a:noFill/>
+          <a:ln/>
+        </p:spPr>
+        <p:txBody>
+          <a:bodyPr wrap="square" lIns="0" tIns="0" rIns="0" bIns="0" rtlCol="0" anchor="ctr"/>
+          <a:lstStyle/>
+          <a:p>
+            <a:pPr indent="0" marL="0">
+              <a:buNone/>
+            </a:pPr>
+            <a:r>
+              <a:rPr lang="en-US" sz="1100" dirty="0">
+                <a:solidFill>
+                  <a:srgbClr val="AFCBE3"/>
+                </a:solidFill>
+                <a:latin typeface="Calibri" pitchFamily="34" charset="0"/>
+                <a:ea typeface="Calibri" pitchFamily="34" charset="-122"/>
+                <a:cs typeface="Calibri" pitchFamily="34" charset="-120"/>
+              </a:rPr>
+              <a:t>EventBridge wakes it: it reads the day and decides tomorrow</a:t>
+            </a:r>
+            <a:endParaRPr lang="en-US" sz="1100" dirty="0"/>
           </a:p>
         </p:txBody>
       </p:sp>

</xml_diff>